<commit_message>
fix(security): resolve DAST session fallback, static link filtering, and mock mode support
</commit_message>
<xml_diff>
--- a/presentation/pione_testmate_presentation.pptx
+++ b/presentation/pione_testmate_presentation.pptx
@@ -4,29 +4,32 @@
   <p:sldMasterIdLst>
     <p:sldMasterId id="2147483648" r:id="rId1"/>
   </p:sldMasterIdLst>
+  <p:notesMasterIdLst>
+    <p:notesMasterId r:id="rId22"/>
+  </p:notesMasterIdLst>
   <p:sldIdLst>
-    <p:sldId id="256" r:id="rId7"/>
-    <p:sldId id="257" r:id="rId8"/>
-    <p:sldId id="258" r:id="rId9"/>
-    <p:sldId id="259" r:id="rId10"/>
-    <p:sldId id="260" r:id="rId11"/>
-    <p:sldId id="261" r:id="rId12"/>
-    <p:sldId id="262" r:id="rId13"/>
-    <p:sldId id="263" r:id="rId14"/>
-    <p:sldId id="264" r:id="rId15"/>
-    <p:sldId id="265" r:id="rId16"/>
-    <p:sldId id="266" r:id="rId17"/>
-    <p:sldId id="267" r:id="rId18"/>
-    <p:sldId id="268" r:id="rId19"/>
-    <p:sldId id="269" r:id="rId20"/>
-    <p:sldId id="270" r:id="rId21"/>
-    <p:sldId id="271" r:id="rId22"/>
-    <p:sldId id="272" r:id="rId23"/>
-    <p:sldId id="273" r:id="rId24"/>
-    <p:sldId id="274" r:id="rId25"/>
-    <p:sldId id="275" r:id="rId26"/>
+    <p:sldId id="256" r:id="rId2"/>
+    <p:sldId id="257" r:id="rId3"/>
+    <p:sldId id="258" r:id="rId4"/>
+    <p:sldId id="259" r:id="rId5"/>
+    <p:sldId id="260" r:id="rId6"/>
+    <p:sldId id="261" r:id="rId7"/>
+    <p:sldId id="262" r:id="rId8"/>
+    <p:sldId id="263" r:id="rId9"/>
+    <p:sldId id="264" r:id="rId10"/>
+    <p:sldId id="265" r:id="rId11"/>
+    <p:sldId id="266" r:id="rId12"/>
+    <p:sldId id="267" r:id="rId13"/>
+    <p:sldId id="268" r:id="rId14"/>
+    <p:sldId id="269" r:id="rId15"/>
+    <p:sldId id="270" r:id="rId16"/>
+    <p:sldId id="271" r:id="rId17"/>
+    <p:sldId id="272" r:id="rId18"/>
+    <p:sldId id="273" r:id="rId19"/>
+    <p:sldId id="274" r:id="rId20"/>
+    <p:sldId id="275" r:id="rId21"/>
   </p:sldIdLst>
-  <p:sldSz cx="12191695" cy="6858000" type="screen4x3"/>
+  <p:sldSz cx="12192000" cy="6858000"/>
   <p:notesSz cx="6858000" cy="9144000"/>
   <p:defaultTextStyle>
     <a:defPPr>
@@ -123,7 +126,635 @@
       </a:defRPr>
     </a:lvl9pPr>
   </p:defaultTextStyle>
+  <p:extLst>
+    <p:ext uri="{EFAFB233-063F-42B5-8137-9DF3F51BA10A}">
+      <p15:sldGuideLst xmlns:p15="http://schemas.microsoft.com/office/powerpoint/2012/main">
+        <p15:guide id="1" orient="horz" pos="2160">
+          <p15:clr>
+            <a:srgbClr val="A4A3A4"/>
+          </p15:clr>
+        </p15:guide>
+        <p15:guide id="2" pos="2880">
+          <p15:clr>
+            <a:srgbClr val="A4A3A4"/>
+          </p15:clr>
+        </p15:guide>
+      </p15:sldGuideLst>
+    </p:ext>
+  </p:extLst>
 </p:presentation>
+</file>
+
+<file path=ppt/changesInfos/changesInfo1.xml><?xml version="1.0" encoding="utf-8"?>
+<pc:chgInfo xmlns:a="http://schemas.openxmlformats.org/drawingml/2006/main" xmlns:r="http://schemas.openxmlformats.org/officeDocument/2006/relationships" xmlns:ac="http://schemas.microsoft.com/office/drawing/2013/main/command" xmlns:pc="http://schemas.microsoft.com/office/powerpoint/2013/main/command">
+  <pc:docChgLst>
+    <pc:chgData name="Deepak Raj" userId="d6b445e7-9dc4-45ad-ba0f-07fe91c04262" providerId="ADAL" clId="{C9D10BB1-77BE-4FB4-8409-07AF18014593}"/>
+    <pc:docChg chg="custSel modSld sldOrd">
+      <pc:chgData name="Deepak Raj" userId="d6b445e7-9dc4-45ad-ba0f-07fe91c04262" providerId="ADAL" clId="{C9D10BB1-77BE-4FB4-8409-07AF18014593}" dt="2026-10-23T13:12:03.342" v="21"/>
+      <pc:docMkLst>
+        <pc:docMk/>
+      </pc:docMkLst>
+      <pc:sldChg chg="modSp mod">
+        <pc:chgData name="Deepak Raj" userId="d6b445e7-9dc4-45ad-ba0f-07fe91c04262" providerId="ADAL" clId="{C9D10BB1-77BE-4FB4-8409-07AF18014593}" dt="2026-10-23T13:10:02.929" v="3" actId="26606"/>
+        <pc:sldMkLst>
+          <pc:docMk/>
+          <pc:sldMk cId="0" sldId="261"/>
+        </pc:sldMkLst>
+        <pc:picChg chg="mod">
+          <ac:chgData name="Deepak Raj" userId="d6b445e7-9dc4-45ad-ba0f-07fe91c04262" providerId="ADAL" clId="{C9D10BB1-77BE-4FB4-8409-07AF18014593}" dt="2026-10-23T13:10:02.929" v="3" actId="26606"/>
+          <ac:picMkLst>
+            <pc:docMk/>
+            <pc:sldMk cId="0" sldId="261"/>
+            <ac:picMk id="7" creationId="{00000000-0000-0000-0000-000000000000}"/>
+          </ac:picMkLst>
+        </pc:picChg>
+      </pc:sldChg>
+      <pc:sldChg chg="modSp mod">
+        <pc:chgData name="Deepak Raj" userId="d6b445e7-9dc4-45ad-ba0f-07fe91c04262" providerId="ADAL" clId="{C9D10BB1-77BE-4FB4-8409-07AF18014593}" dt="2026-10-23T13:10:02.929" v="3" actId="26606"/>
+        <pc:sldMkLst>
+          <pc:docMk/>
+          <pc:sldMk cId="0" sldId="262"/>
+        </pc:sldMkLst>
+        <pc:picChg chg="mod">
+          <ac:chgData name="Deepak Raj" userId="d6b445e7-9dc4-45ad-ba0f-07fe91c04262" providerId="ADAL" clId="{C9D10BB1-77BE-4FB4-8409-07AF18014593}" dt="2026-10-23T13:10:02.929" v="3" actId="26606"/>
+          <ac:picMkLst>
+            <pc:docMk/>
+            <pc:sldMk cId="0" sldId="262"/>
+            <ac:picMk id="7" creationId="{00000000-0000-0000-0000-000000000000}"/>
+          </ac:picMkLst>
+        </pc:picChg>
+      </pc:sldChg>
+      <pc:sldChg chg="modSp mod">
+        <pc:chgData name="Deepak Raj" userId="d6b445e7-9dc4-45ad-ba0f-07fe91c04262" providerId="ADAL" clId="{C9D10BB1-77BE-4FB4-8409-07AF18014593}" dt="2026-10-23T13:10:02.929" v="3" actId="26606"/>
+        <pc:sldMkLst>
+          <pc:docMk/>
+          <pc:sldMk cId="0" sldId="263"/>
+        </pc:sldMkLst>
+        <pc:picChg chg="mod">
+          <ac:chgData name="Deepak Raj" userId="d6b445e7-9dc4-45ad-ba0f-07fe91c04262" providerId="ADAL" clId="{C9D10BB1-77BE-4FB4-8409-07AF18014593}" dt="2026-10-23T13:10:02.929" v="3" actId="26606"/>
+          <ac:picMkLst>
+            <pc:docMk/>
+            <pc:sldMk cId="0" sldId="263"/>
+            <ac:picMk id="7" creationId="{00000000-0000-0000-0000-000000000000}"/>
+          </ac:picMkLst>
+        </pc:picChg>
+      </pc:sldChg>
+      <pc:sldChg chg="modSp mod">
+        <pc:chgData name="Deepak Raj" userId="d6b445e7-9dc4-45ad-ba0f-07fe91c04262" providerId="ADAL" clId="{C9D10BB1-77BE-4FB4-8409-07AF18014593}" dt="2026-10-23T13:10:02.929" v="3" actId="26606"/>
+        <pc:sldMkLst>
+          <pc:docMk/>
+          <pc:sldMk cId="0" sldId="264"/>
+        </pc:sldMkLst>
+        <pc:picChg chg="mod">
+          <ac:chgData name="Deepak Raj" userId="d6b445e7-9dc4-45ad-ba0f-07fe91c04262" providerId="ADAL" clId="{C9D10BB1-77BE-4FB4-8409-07AF18014593}" dt="2026-10-23T13:10:02.929" v="3" actId="26606"/>
+          <ac:picMkLst>
+            <pc:docMk/>
+            <pc:sldMk cId="0" sldId="264"/>
+            <ac:picMk id="7" creationId="{00000000-0000-0000-0000-000000000000}"/>
+          </ac:picMkLst>
+        </pc:picChg>
+      </pc:sldChg>
+      <pc:sldChg chg="modSp mod">
+        <pc:chgData name="Deepak Raj" userId="d6b445e7-9dc4-45ad-ba0f-07fe91c04262" providerId="ADAL" clId="{C9D10BB1-77BE-4FB4-8409-07AF18014593}" dt="2026-10-23T13:10:02.929" v="3" actId="26606"/>
+        <pc:sldMkLst>
+          <pc:docMk/>
+          <pc:sldMk cId="0" sldId="265"/>
+        </pc:sldMkLst>
+        <pc:picChg chg="mod">
+          <ac:chgData name="Deepak Raj" userId="d6b445e7-9dc4-45ad-ba0f-07fe91c04262" providerId="ADAL" clId="{C9D10BB1-77BE-4FB4-8409-07AF18014593}" dt="2026-10-23T13:10:02.929" v="3" actId="26606"/>
+          <ac:picMkLst>
+            <pc:docMk/>
+            <pc:sldMk cId="0" sldId="265"/>
+            <ac:picMk id="7" creationId="{00000000-0000-0000-0000-000000000000}"/>
+          </ac:picMkLst>
+        </pc:picChg>
+      </pc:sldChg>
+      <pc:sldChg chg="modSp mod">
+        <pc:chgData name="Deepak Raj" userId="d6b445e7-9dc4-45ad-ba0f-07fe91c04262" providerId="ADAL" clId="{C9D10BB1-77BE-4FB4-8409-07AF18014593}" dt="2026-10-23T13:10:02.929" v="3" actId="26606"/>
+        <pc:sldMkLst>
+          <pc:docMk/>
+          <pc:sldMk cId="0" sldId="266"/>
+        </pc:sldMkLst>
+        <pc:picChg chg="mod">
+          <ac:chgData name="Deepak Raj" userId="d6b445e7-9dc4-45ad-ba0f-07fe91c04262" providerId="ADAL" clId="{C9D10BB1-77BE-4FB4-8409-07AF18014593}" dt="2026-10-23T13:10:02.929" v="3" actId="26606"/>
+          <ac:picMkLst>
+            <pc:docMk/>
+            <pc:sldMk cId="0" sldId="266"/>
+            <ac:picMk id="7" creationId="{00000000-0000-0000-0000-000000000000}"/>
+          </ac:picMkLst>
+        </pc:picChg>
+      </pc:sldChg>
+      <pc:sldChg chg="modSp mod">
+        <pc:chgData name="Deepak Raj" userId="d6b445e7-9dc4-45ad-ba0f-07fe91c04262" providerId="ADAL" clId="{C9D10BB1-77BE-4FB4-8409-07AF18014593}" dt="2026-10-23T13:10:02.929" v="3" actId="26606"/>
+        <pc:sldMkLst>
+          <pc:docMk/>
+          <pc:sldMk cId="0" sldId="267"/>
+        </pc:sldMkLst>
+        <pc:picChg chg="mod">
+          <ac:chgData name="Deepak Raj" userId="d6b445e7-9dc4-45ad-ba0f-07fe91c04262" providerId="ADAL" clId="{C9D10BB1-77BE-4FB4-8409-07AF18014593}" dt="2026-10-23T13:10:02.929" v="3" actId="26606"/>
+          <ac:picMkLst>
+            <pc:docMk/>
+            <pc:sldMk cId="0" sldId="267"/>
+            <ac:picMk id="7" creationId="{00000000-0000-0000-0000-000000000000}"/>
+          </ac:picMkLst>
+        </pc:picChg>
+      </pc:sldChg>
+      <pc:sldChg chg="modSp mod">
+        <pc:chgData name="Deepak Raj" userId="d6b445e7-9dc4-45ad-ba0f-07fe91c04262" providerId="ADAL" clId="{C9D10BB1-77BE-4FB4-8409-07AF18014593}" dt="2026-10-23T13:11:51.077" v="17" actId="1037"/>
+        <pc:sldMkLst>
+          <pc:docMk/>
+          <pc:sldMk cId="0" sldId="268"/>
+        </pc:sldMkLst>
+        <pc:picChg chg="mod">
+          <ac:chgData name="Deepak Raj" userId="d6b445e7-9dc4-45ad-ba0f-07fe91c04262" providerId="ADAL" clId="{C9D10BB1-77BE-4FB4-8409-07AF18014593}" dt="2026-10-23T13:11:51.077" v="17" actId="1037"/>
+          <ac:picMkLst>
+            <pc:docMk/>
+            <pc:sldMk cId="0" sldId="268"/>
+            <ac:picMk id="7" creationId="{00000000-0000-0000-0000-000000000000}"/>
+          </ac:picMkLst>
+        </pc:picChg>
+      </pc:sldChg>
+      <pc:sldChg chg="modSp mod ord">
+        <pc:chgData name="Deepak Raj" userId="d6b445e7-9dc4-45ad-ba0f-07fe91c04262" providerId="ADAL" clId="{C9D10BB1-77BE-4FB4-8409-07AF18014593}" dt="2026-10-23T13:12:03.342" v="21"/>
+        <pc:sldMkLst>
+          <pc:docMk/>
+          <pc:sldMk cId="0" sldId="269"/>
+        </pc:sldMkLst>
+        <pc:picChg chg="mod">
+          <ac:chgData name="Deepak Raj" userId="d6b445e7-9dc4-45ad-ba0f-07fe91c04262" providerId="ADAL" clId="{C9D10BB1-77BE-4FB4-8409-07AF18014593}" dt="2026-10-23T13:10:02.929" v="3" actId="26606"/>
+          <ac:picMkLst>
+            <pc:docMk/>
+            <pc:sldMk cId="0" sldId="269"/>
+            <ac:picMk id="7" creationId="{00000000-0000-0000-0000-000000000000}"/>
+          </ac:picMkLst>
+        </pc:picChg>
+      </pc:sldChg>
+      <pc:sldChg chg="modSp mod">
+        <pc:chgData name="Deepak Raj" userId="d6b445e7-9dc4-45ad-ba0f-07fe91c04262" providerId="ADAL" clId="{C9D10BB1-77BE-4FB4-8409-07AF18014593}" dt="2026-10-23T13:10:02.929" v="3" actId="26606"/>
+        <pc:sldMkLst>
+          <pc:docMk/>
+          <pc:sldMk cId="0" sldId="270"/>
+        </pc:sldMkLst>
+        <pc:picChg chg="mod">
+          <ac:chgData name="Deepak Raj" userId="d6b445e7-9dc4-45ad-ba0f-07fe91c04262" providerId="ADAL" clId="{C9D10BB1-77BE-4FB4-8409-07AF18014593}" dt="2026-10-23T13:10:02.929" v="3" actId="26606"/>
+          <ac:picMkLst>
+            <pc:docMk/>
+            <pc:sldMk cId="0" sldId="270"/>
+            <ac:picMk id="7" creationId="{00000000-0000-0000-0000-000000000000}"/>
+          </ac:picMkLst>
+        </pc:picChg>
+      </pc:sldChg>
+      <pc:sldChg chg="modSp mod">
+        <pc:chgData name="Deepak Raj" userId="d6b445e7-9dc4-45ad-ba0f-07fe91c04262" providerId="ADAL" clId="{C9D10BB1-77BE-4FB4-8409-07AF18014593}" dt="2026-10-23T13:10:02.929" v="3" actId="26606"/>
+        <pc:sldMkLst>
+          <pc:docMk/>
+          <pc:sldMk cId="0" sldId="271"/>
+        </pc:sldMkLst>
+        <pc:picChg chg="mod">
+          <ac:chgData name="Deepak Raj" userId="d6b445e7-9dc4-45ad-ba0f-07fe91c04262" providerId="ADAL" clId="{C9D10BB1-77BE-4FB4-8409-07AF18014593}" dt="2026-10-23T13:10:02.929" v="3" actId="26606"/>
+          <ac:picMkLst>
+            <pc:docMk/>
+            <pc:sldMk cId="0" sldId="271"/>
+            <ac:picMk id="7" creationId="{00000000-0000-0000-0000-000000000000}"/>
+          </ac:picMkLst>
+        </pc:picChg>
+      </pc:sldChg>
+    </pc:docChg>
+  </pc:docChgLst>
+</pc:chgInfo>
+</file>
+
+<file path=ppt/notesMasters/notesMaster1.xml><?xml version="1.0" encoding="utf-8"?>
+<p:notesMaster xmlns:a="http://schemas.openxmlformats.org/drawingml/2006/main" xmlns:r="http://schemas.openxmlformats.org/officeDocument/2006/relationships" xmlns:p="http://schemas.openxmlformats.org/presentationml/2006/main">
+  <p:cSld>
+    <p:bg>
+      <p:bgRef idx="1001">
+        <a:schemeClr val="bg1"/>
+      </p:bgRef>
+    </p:bg>
+    <p:spTree>
+      <p:nvGrpSpPr>
+        <p:cNvPr id="1" name=""/>
+        <p:cNvGrpSpPr/>
+        <p:nvPr/>
+      </p:nvGrpSpPr>
+      <p:grpSpPr>
+        <a:xfrm>
+          <a:off x="0" y="0"/>
+          <a:ext cx="0" cy="0"/>
+          <a:chOff x="0" y="0"/>
+          <a:chExt cx="0" cy="0"/>
+        </a:xfrm>
+      </p:grpSpPr>
+      <p:sp>
+        <p:nvSpPr>
+          <p:cNvPr id="2" name="Header Placeholder 1"/>
+          <p:cNvSpPr>
+            <a:spLocks noGrp="1"/>
+          </p:cNvSpPr>
+          <p:nvPr>
+            <p:ph type="hdr" sz="quarter"/>
+          </p:nvPr>
+        </p:nvSpPr>
+        <p:spPr>
+          <a:xfrm>
+            <a:off x="0" y="0"/>
+            <a:ext cx="2971800" cy="458788"/>
+          </a:xfrm>
+          <a:prstGeom prst="rect">
+            <a:avLst/>
+          </a:prstGeom>
+        </p:spPr>
+        <p:txBody>
+          <a:bodyPr vert="horz" lIns="91440" tIns="45720" rIns="91440" bIns="45720" rtlCol="0"/>
+          <a:lstStyle>
+            <a:lvl1pPr algn="l">
+              <a:defRPr sz="1200"/>
+            </a:lvl1pPr>
+          </a:lstStyle>
+          <a:p>
+            <a:endParaRPr lang="en-US"/>
+          </a:p>
+        </p:txBody>
+      </p:sp>
+      <p:sp>
+        <p:nvSpPr>
+          <p:cNvPr id="3" name="Date Placeholder 2"/>
+          <p:cNvSpPr>
+            <a:spLocks noGrp="1"/>
+          </p:cNvSpPr>
+          <p:nvPr>
+            <p:ph type="dt" idx="1"/>
+          </p:nvPr>
+        </p:nvSpPr>
+        <p:spPr>
+          <a:xfrm>
+            <a:off x="3884613" y="0"/>
+            <a:ext cx="2971800" cy="458788"/>
+          </a:xfrm>
+          <a:prstGeom prst="rect">
+            <a:avLst/>
+          </a:prstGeom>
+        </p:spPr>
+        <p:txBody>
+          <a:bodyPr vert="horz" lIns="91440" tIns="45720" rIns="91440" bIns="45720" rtlCol="0"/>
+          <a:lstStyle>
+            <a:lvl1pPr algn="r">
+              <a:defRPr sz="1200"/>
+            </a:lvl1pPr>
+          </a:lstStyle>
+          <a:p>
+            <a:fld id="{63535F24-5DFD-432D-93AF-75040FF3CF90}" type="datetimeFigureOut">
+              <a:rPr lang="en-US" smtClean="0"/>
+              <a:t>10/23/2026</a:t>
+            </a:fld>
+            <a:endParaRPr lang="en-US"/>
+          </a:p>
+        </p:txBody>
+      </p:sp>
+      <p:sp>
+        <p:nvSpPr>
+          <p:cNvPr id="4" name="Slide Image Placeholder 3"/>
+          <p:cNvSpPr>
+            <a:spLocks noGrp="1" noRot="1" noChangeAspect="1"/>
+          </p:cNvSpPr>
+          <p:nvPr>
+            <p:ph type="sldImg" idx="2"/>
+          </p:nvPr>
+        </p:nvSpPr>
+        <p:spPr>
+          <a:xfrm>
+            <a:off x="685800" y="1143000"/>
+            <a:ext cx="5486400" cy="3086100"/>
+          </a:xfrm>
+          <a:prstGeom prst="rect">
+            <a:avLst/>
+          </a:prstGeom>
+          <a:noFill/>
+          <a:ln w="12700">
+            <a:solidFill>
+              <a:prstClr val="black"/>
+            </a:solidFill>
+          </a:ln>
+        </p:spPr>
+        <p:txBody>
+          <a:bodyPr vert="horz" lIns="91440" tIns="45720" rIns="91440" bIns="45720" rtlCol="0" anchor="ctr"/>
+          <a:lstStyle/>
+          <a:p>
+            <a:endParaRPr lang="en-US"/>
+          </a:p>
+        </p:txBody>
+      </p:sp>
+      <p:sp>
+        <p:nvSpPr>
+          <p:cNvPr id="5" name="Notes Placeholder 4"/>
+          <p:cNvSpPr>
+            <a:spLocks noGrp="1"/>
+          </p:cNvSpPr>
+          <p:nvPr>
+            <p:ph type="body" sz="quarter" idx="3"/>
+          </p:nvPr>
+        </p:nvSpPr>
+        <p:spPr>
+          <a:xfrm>
+            <a:off x="685800" y="4400550"/>
+            <a:ext cx="5486400" cy="3600450"/>
+          </a:xfrm>
+          <a:prstGeom prst="rect">
+            <a:avLst/>
+          </a:prstGeom>
+        </p:spPr>
+        <p:txBody>
+          <a:bodyPr vert="horz" lIns="91440" tIns="45720" rIns="91440" bIns="45720" rtlCol="0"/>
+          <a:lstStyle/>
+          <a:p>
+            <a:pPr lvl="0"/>
+            <a:r>
+              <a:rPr lang="en-US"/>
+              <a:t>Click to edit Master text styles</a:t>
+            </a:r>
+          </a:p>
+          <a:p>
+            <a:pPr lvl="1"/>
+            <a:r>
+              <a:rPr lang="en-US"/>
+              <a:t>Second level</a:t>
+            </a:r>
+          </a:p>
+          <a:p>
+            <a:pPr lvl="2"/>
+            <a:r>
+              <a:rPr lang="en-US"/>
+              <a:t>Third level</a:t>
+            </a:r>
+          </a:p>
+          <a:p>
+            <a:pPr lvl="3"/>
+            <a:r>
+              <a:rPr lang="en-US"/>
+              <a:t>Fourth level</a:t>
+            </a:r>
+          </a:p>
+          <a:p>
+            <a:pPr lvl="4"/>
+            <a:r>
+              <a:rPr lang="en-US"/>
+              <a:t>Fifth level</a:t>
+            </a:r>
+          </a:p>
+        </p:txBody>
+      </p:sp>
+      <p:sp>
+        <p:nvSpPr>
+          <p:cNvPr id="6" name="Footer Placeholder 5"/>
+          <p:cNvSpPr>
+            <a:spLocks noGrp="1"/>
+          </p:cNvSpPr>
+          <p:nvPr>
+            <p:ph type="ftr" sz="quarter" idx="4"/>
+          </p:nvPr>
+        </p:nvSpPr>
+        <p:spPr>
+          <a:xfrm>
+            <a:off x="0" y="8685213"/>
+            <a:ext cx="2971800" cy="458787"/>
+          </a:xfrm>
+          <a:prstGeom prst="rect">
+            <a:avLst/>
+          </a:prstGeom>
+        </p:spPr>
+        <p:txBody>
+          <a:bodyPr vert="horz" lIns="91440" tIns="45720" rIns="91440" bIns="45720" rtlCol="0" anchor="b"/>
+          <a:lstStyle>
+            <a:lvl1pPr algn="l">
+              <a:defRPr sz="1200"/>
+            </a:lvl1pPr>
+          </a:lstStyle>
+          <a:p>
+            <a:endParaRPr lang="en-US"/>
+          </a:p>
+        </p:txBody>
+      </p:sp>
+      <p:sp>
+        <p:nvSpPr>
+          <p:cNvPr id="7" name="Slide Number Placeholder 6"/>
+          <p:cNvSpPr>
+            <a:spLocks noGrp="1"/>
+          </p:cNvSpPr>
+          <p:nvPr>
+            <p:ph type="sldNum" sz="quarter" idx="5"/>
+          </p:nvPr>
+        </p:nvSpPr>
+        <p:spPr>
+          <a:xfrm>
+            <a:off x="3884613" y="8685213"/>
+            <a:ext cx="2971800" cy="458787"/>
+          </a:xfrm>
+          <a:prstGeom prst="rect">
+            <a:avLst/>
+          </a:prstGeom>
+        </p:spPr>
+        <p:txBody>
+          <a:bodyPr vert="horz" lIns="91440" tIns="45720" rIns="91440" bIns="45720" rtlCol="0" anchor="b"/>
+          <a:lstStyle>
+            <a:lvl1pPr algn="r">
+              <a:defRPr sz="1200"/>
+            </a:lvl1pPr>
+          </a:lstStyle>
+          <a:p>
+            <a:fld id="{3C953744-B112-4379-8299-2FC74C2341AE}" type="slidenum">
+              <a:rPr lang="en-US" smtClean="0"/>
+              <a:t>‹#›</a:t>
+            </a:fld>
+            <a:endParaRPr lang="en-US"/>
+          </a:p>
+        </p:txBody>
+      </p:sp>
+    </p:spTree>
+    <p:extLst>
+      <p:ext uri="{BB962C8B-B14F-4D97-AF65-F5344CB8AC3E}">
+        <p14:creationId xmlns:p14="http://schemas.microsoft.com/office/powerpoint/2010/main" val="4219052259"/>
+      </p:ext>
+    </p:extLst>
+  </p:cSld>
+  <p:clrMap bg1="lt1" tx1="dk1" bg2="lt2" tx2="dk2" accent1="accent1" accent2="accent2" accent3="accent3" accent4="accent4" accent5="accent5" accent6="accent6" hlink="hlink" folHlink="folHlink"/>
+  <p:notesStyle>
+    <a:lvl1pPr marL="0" algn="l" defTabSz="914400" rtl="0" eaLnBrk="1" latinLnBrk="0" hangingPunct="1">
+      <a:defRPr sz="1200" kern="1200">
+        <a:solidFill>
+          <a:schemeClr val="tx1"/>
+        </a:solidFill>
+        <a:latin typeface="+mn-lt"/>
+        <a:ea typeface="+mn-ea"/>
+        <a:cs typeface="+mn-cs"/>
+      </a:defRPr>
+    </a:lvl1pPr>
+    <a:lvl2pPr marL="457200" algn="l" defTabSz="914400" rtl="0" eaLnBrk="1" latinLnBrk="0" hangingPunct="1">
+      <a:defRPr sz="1200" kern="1200">
+        <a:solidFill>
+          <a:schemeClr val="tx1"/>
+        </a:solidFill>
+        <a:latin typeface="+mn-lt"/>
+        <a:ea typeface="+mn-ea"/>
+        <a:cs typeface="+mn-cs"/>
+      </a:defRPr>
+    </a:lvl2pPr>
+    <a:lvl3pPr marL="914400" algn="l" defTabSz="914400" rtl="0" eaLnBrk="1" latinLnBrk="0" hangingPunct="1">
+      <a:defRPr sz="1200" kern="1200">
+        <a:solidFill>
+          <a:schemeClr val="tx1"/>
+        </a:solidFill>
+        <a:latin typeface="+mn-lt"/>
+        <a:ea typeface="+mn-ea"/>
+        <a:cs typeface="+mn-cs"/>
+      </a:defRPr>
+    </a:lvl3pPr>
+    <a:lvl4pPr marL="1371600" algn="l" defTabSz="914400" rtl="0" eaLnBrk="1" latinLnBrk="0" hangingPunct="1">
+      <a:defRPr sz="1200" kern="1200">
+        <a:solidFill>
+          <a:schemeClr val="tx1"/>
+        </a:solidFill>
+        <a:latin typeface="+mn-lt"/>
+        <a:ea typeface="+mn-ea"/>
+        <a:cs typeface="+mn-cs"/>
+      </a:defRPr>
+    </a:lvl4pPr>
+    <a:lvl5pPr marL="1828800" algn="l" defTabSz="914400" rtl="0" eaLnBrk="1" latinLnBrk="0" hangingPunct="1">
+      <a:defRPr sz="1200" kern="1200">
+        <a:solidFill>
+          <a:schemeClr val="tx1"/>
+        </a:solidFill>
+        <a:latin typeface="+mn-lt"/>
+        <a:ea typeface="+mn-ea"/>
+        <a:cs typeface="+mn-cs"/>
+      </a:defRPr>
+    </a:lvl5pPr>
+    <a:lvl6pPr marL="2286000" algn="l" defTabSz="914400" rtl="0" eaLnBrk="1" latinLnBrk="0" hangingPunct="1">
+      <a:defRPr sz="1200" kern="1200">
+        <a:solidFill>
+          <a:schemeClr val="tx1"/>
+        </a:solidFill>
+        <a:latin typeface="+mn-lt"/>
+        <a:ea typeface="+mn-ea"/>
+        <a:cs typeface="+mn-cs"/>
+      </a:defRPr>
+    </a:lvl6pPr>
+    <a:lvl7pPr marL="2743200" algn="l" defTabSz="914400" rtl="0" eaLnBrk="1" latinLnBrk="0" hangingPunct="1">
+      <a:defRPr sz="1200" kern="1200">
+        <a:solidFill>
+          <a:schemeClr val="tx1"/>
+        </a:solidFill>
+        <a:latin typeface="+mn-lt"/>
+        <a:ea typeface="+mn-ea"/>
+        <a:cs typeface="+mn-cs"/>
+      </a:defRPr>
+    </a:lvl7pPr>
+    <a:lvl8pPr marL="3200400" algn="l" defTabSz="914400" rtl="0" eaLnBrk="1" latinLnBrk="0" hangingPunct="1">
+      <a:defRPr sz="1200" kern="1200">
+        <a:solidFill>
+          <a:schemeClr val="tx1"/>
+        </a:solidFill>
+        <a:latin typeface="+mn-lt"/>
+        <a:ea typeface="+mn-ea"/>
+        <a:cs typeface="+mn-cs"/>
+      </a:defRPr>
+    </a:lvl8pPr>
+    <a:lvl9pPr marL="3657600" algn="l" defTabSz="914400" rtl="0" eaLnBrk="1" latinLnBrk="0" hangingPunct="1">
+      <a:defRPr sz="1200" kern="1200">
+        <a:solidFill>
+          <a:schemeClr val="tx1"/>
+        </a:solidFill>
+        <a:latin typeface="+mn-lt"/>
+        <a:ea typeface="+mn-ea"/>
+        <a:cs typeface="+mn-cs"/>
+      </a:defRPr>
+    </a:lvl9pPr>
+  </p:notesStyle>
+</p:notesMaster>
+</file>
+
+<file path=ppt/notesSlides/notesSlide1.xml><?xml version="1.0" encoding="utf-8"?>
+<p:notes xmlns:a="http://schemas.openxmlformats.org/drawingml/2006/main" xmlns:r="http://schemas.openxmlformats.org/officeDocument/2006/relationships" xmlns:p="http://schemas.openxmlformats.org/presentationml/2006/main">
+  <p:cSld>
+    <p:spTree>
+      <p:nvGrpSpPr>
+        <p:cNvPr id="1" name=""/>
+        <p:cNvGrpSpPr/>
+        <p:nvPr/>
+      </p:nvGrpSpPr>
+      <p:grpSpPr>
+        <a:xfrm>
+          <a:off x="0" y="0"/>
+          <a:ext cx="0" cy="0"/>
+          <a:chOff x="0" y="0"/>
+          <a:chExt cx="0" cy="0"/>
+        </a:xfrm>
+      </p:grpSpPr>
+      <p:sp>
+        <p:nvSpPr>
+          <p:cNvPr id="2" name="Slide Image Placeholder 1"/>
+          <p:cNvSpPr>
+            <a:spLocks noGrp="1" noRot="1" noChangeAspect="1"/>
+          </p:cNvSpPr>
+          <p:nvPr>
+            <p:ph type="sldImg"/>
+          </p:nvPr>
+        </p:nvSpPr>
+        <p:spPr/>
+      </p:sp>
+      <p:sp>
+        <p:nvSpPr>
+          <p:cNvPr id="3" name="Notes Placeholder 2"/>
+          <p:cNvSpPr>
+            <a:spLocks noGrp="1"/>
+          </p:cNvSpPr>
+          <p:nvPr>
+            <p:ph type="body" idx="1"/>
+          </p:nvPr>
+        </p:nvSpPr>
+        <p:spPr/>
+        <p:txBody>
+          <a:bodyPr/>
+          <a:lstStyle/>
+          <a:p>
+            <a:endParaRPr lang="en-US" dirty="0"/>
+          </a:p>
+        </p:txBody>
+      </p:sp>
+      <p:sp>
+        <p:nvSpPr>
+          <p:cNvPr id="4" name="Slide Number Placeholder 3"/>
+          <p:cNvSpPr>
+            <a:spLocks noGrp="1"/>
+          </p:cNvSpPr>
+          <p:nvPr>
+            <p:ph type="sldNum" sz="quarter" idx="5"/>
+          </p:nvPr>
+        </p:nvSpPr>
+        <p:spPr/>
+        <p:txBody>
+          <a:bodyPr/>
+          <a:lstStyle/>
+          <a:p>
+            <a:fld id="{3C953744-B112-4379-8299-2FC74C2341AE}" type="slidenum">
+              <a:rPr lang="en-US" smtClean="0"/>
+              <a:t>13</a:t>
+            </a:fld>
+            <a:endParaRPr lang="en-US"/>
+          </a:p>
+        </p:txBody>
+      </p:sp>
+    </p:spTree>
+    <p:extLst>
+      <p:ext uri="{BB962C8B-B14F-4D97-AF65-F5344CB8AC3E}">
+        <p14:creationId xmlns:p14="http://schemas.microsoft.com/office/powerpoint/2010/main" val="2605789185"/>
+      </p:ext>
+    </p:extLst>
+  </p:cSld>
+  <p:clrMapOvr>
+    <a:masterClrMapping/>
+  </p:clrMapOvr>
+</p:notes>
 </file>
 
 <file path=ppt/slideLayouts/slideLayout1.xml><?xml version="1.0" encoding="utf-8"?>
@@ -164,10 +795,9 @@
           <a:lstStyle/>
           <a:p>
             <a:r>
-              <a:rPr lang="en-US" smtClean="0"/>
+              <a:rPr lang="en-US"/>
               <a:t>Click to edit Master title style</a:t>
             </a:r>
-            <a:endParaRPr lang="en-US"/>
           </a:p>
         </p:txBody>
       </p:sp>
@@ -283,10 +913,9 @@
           </a:lstStyle>
           <a:p>
             <a:r>
-              <a:rPr lang="en-US" smtClean="0"/>
+              <a:rPr lang="en-US"/>
               <a:t>Click to edit Master subtitle style</a:t>
             </a:r>
-            <a:endParaRPr lang="en-US"/>
           </a:p>
         </p:txBody>
       </p:sp>
@@ -307,7 +936,7 @@
           <a:p>
             <a:fld id="{5BCAD085-E8A6-8845-BD4E-CB4CCA059FC4}" type="datetimeFigureOut">
               <a:rPr lang="en-US" smtClean="0"/>
-              <a:t>1/27/13</a:t>
+              <a:t>10/23/2026</a:t>
             </a:fld>
             <a:endParaRPr lang="en-US"/>
           </a:p>
@@ -401,10 +1030,9 @@
           <a:lstStyle/>
           <a:p>
             <a:r>
-              <a:rPr lang="en-US" smtClean="0"/>
+              <a:rPr lang="en-US"/>
               <a:t>Click to edit Master title style</a:t>
             </a:r>
-            <a:endParaRPr lang="en-US"/>
           </a:p>
         </p:txBody>
       </p:sp>
@@ -425,38 +1053,37 @@
           <a:p>
             <a:pPr lvl="0"/>
             <a:r>
-              <a:rPr lang="en-US" smtClean="0"/>
+              <a:rPr lang="en-US"/>
               <a:t>Click to edit Master text styles</a:t>
             </a:r>
           </a:p>
           <a:p>
             <a:pPr lvl="1"/>
             <a:r>
-              <a:rPr lang="en-US" smtClean="0"/>
+              <a:rPr lang="en-US"/>
               <a:t>Second level</a:t>
             </a:r>
           </a:p>
           <a:p>
             <a:pPr lvl="2"/>
             <a:r>
-              <a:rPr lang="en-US" smtClean="0"/>
+              <a:rPr lang="en-US"/>
               <a:t>Third level</a:t>
             </a:r>
           </a:p>
           <a:p>
             <a:pPr lvl="3"/>
             <a:r>
-              <a:rPr lang="en-US" smtClean="0"/>
+              <a:rPr lang="en-US"/>
               <a:t>Fourth level</a:t>
             </a:r>
           </a:p>
           <a:p>
             <a:pPr lvl="4"/>
             <a:r>
-              <a:rPr lang="en-US" smtClean="0"/>
+              <a:rPr lang="en-US"/>
               <a:t>Fifth level</a:t>
             </a:r>
-            <a:endParaRPr lang="en-US"/>
           </a:p>
         </p:txBody>
       </p:sp>
@@ -477,7 +1104,7 @@
           <a:p>
             <a:fld id="{5BCAD085-E8A6-8845-BD4E-CB4CCA059FC4}" type="datetimeFigureOut">
               <a:rPr lang="en-US" smtClean="0"/>
-              <a:t>1/27/13</a:t>
+              <a:t>10/23/2026</a:t>
             </a:fld>
             <a:endParaRPr lang="en-US"/>
           </a:p>
@@ -576,10 +1203,9 @@
           <a:lstStyle/>
           <a:p>
             <a:r>
-              <a:rPr lang="en-US" smtClean="0"/>
+              <a:rPr lang="en-US"/>
               <a:t>Click to edit Master title style</a:t>
             </a:r>
-            <a:endParaRPr lang="en-US"/>
           </a:p>
         </p:txBody>
       </p:sp>
@@ -605,38 +1231,37 @@
           <a:p>
             <a:pPr lvl="0"/>
             <a:r>
-              <a:rPr lang="en-US" smtClean="0"/>
+              <a:rPr lang="en-US"/>
               <a:t>Click to edit Master text styles</a:t>
             </a:r>
           </a:p>
           <a:p>
             <a:pPr lvl="1"/>
             <a:r>
-              <a:rPr lang="en-US" smtClean="0"/>
+              <a:rPr lang="en-US"/>
               <a:t>Second level</a:t>
             </a:r>
           </a:p>
           <a:p>
             <a:pPr lvl="2"/>
             <a:r>
-              <a:rPr lang="en-US" smtClean="0"/>
+              <a:rPr lang="en-US"/>
               <a:t>Third level</a:t>
             </a:r>
           </a:p>
           <a:p>
             <a:pPr lvl="3"/>
             <a:r>
-              <a:rPr lang="en-US" smtClean="0"/>
+              <a:rPr lang="en-US"/>
               <a:t>Fourth level</a:t>
             </a:r>
           </a:p>
           <a:p>
             <a:pPr lvl="4"/>
             <a:r>
-              <a:rPr lang="en-US" smtClean="0"/>
+              <a:rPr lang="en-US"/>
               <a:t>Fifth level</a:t>
             </a:r>
-            <a:endParaRPr lang="en-US"/>
           </a:p>
         </p:txBody>
       </p:sp>
@@ -657,7 +1282,7 @@
           <a:p>
             <a:fld id="{5BCAD085-E8A6-8845-BD4E-CB4CCA059FC4}" type="datetimeFigureOut">
               <a:rPr lang="en-US" smtClean="0"/>
-              <a:t>1/27/13</a:t>
+              <a:t>10/23/2026</a:t>
             </a:fld>
             <a:endParaRPr lang="en-US"/>
           </a:p>
@@ -751,10 +1376,9 @@
           <a:lstStyle/>
           <a:p>
             <a:r>
-              <a:rPr lang="en-US" smtClean="0"/>
+              <a:rPr lang="en-US"/>
               <a:t>Click to edit Master title style</a:t>
             </a:r>
-            <a:endParaRPr lang="en-US"/>
           </a:p>
         </p:txBody>
       </p:sp>
@@ -775,38 +1399,37 @@
           <a:p>
             <a:pPr lvl="0"/>
             <a:r>
-              <a:rPr lang="en-US" smtClean="0"/>
+              <a:rPr lang="en-US"/>
               <a:t>Click to edit Master text styles</a:t>
             </a:r>
           </a:p>
           <a:p>
             <a:pPr lvl="1"/>
             <a:r>
-              <a:rPr lang="en-US" smtClean="0"/>
+              <a:rPr lang="en-US"/>
               <a:t>Second level</a:t>
             </a:r>
           </a:p>
           <a:p>
             <a:pPr lvl="2"/>
             <a:r>
-              <a:rPr lang="en-US" smtClean="0"/>
+              <a:rPr lang="en-US"/>
               <a:t>Third level</a:t>
             </a:r>
           </a:p>
           <a:p>
             <a:pPr lvl="3"/>
             <a:r>
-              <a:rPr lang="en-US" smtClean="0"/>
+              <a:rPr lang="en-US"/>
               <a:t>Fourth level</a:t>
             </a:r>
           </a:p>
           <a:p>
             <a:pPr lvl="4"/>
             <a:r>
-              <a:rPr lang="en-US" smtClean="0"/>
+              <a:rPr lang="en-US"/>
               <a:t>Fifth level</a:t>
             </a:r>
-            <a:endParaRPr lang="en-US"/>
           </a:p>
         </p:txBody>
       </p:sp>
@@ -827,7 +1450,7 @@
           <a:p>
             <a:fld id="{5BCAD085-E8A6-8845-BD4E-CB4CCA059FC4}" type="datetimeFigureOut">
               <a:rPr lang="en-US" smtClean="0"/>
-              <a:t>1/27/13</a:t>
+              <a:t>10/23/2026</a:t>
             </a:fld>
             <a:endParaRPr lang="en-US"/>
           </a:p>
@@ -930,10 +1553,9 @@
           </a:lstStyle>
           <a:p>
             <a:r>
-              <a:rPr lang="en-US" smtClean="0"/>
+              <a:rPr lang="en-US"/>
               <a:t>Click to edit Master title style</a:t>
             </a:r>
-            <a:endParaRPr lang="en-US"/>
           </a:p>
         </p:txBody>
       </p:sp>
@@ -1050,7 +1672,7 @@
           <a:p>
             <a:pPr lvl="0"/>
             <a:r>
-              <a:rPr lang="en-US" smtClean="0"/>
+              <a:rPr lang="en-US"/>
               <a:t>Click to edit Master text styles</a:t>
             </a:r>
           </a:p>
@@ -1073,7 +1695,7 @@
           <a:p>
             <a:fld id="{5BCAD085-E8A6-8845-BD4E-CB4CCA059FC4}" type="datetimeFigureOut">
               <a:rPr lang="en-US" smtClean="0"/>
-              <a:t>1/27/13</a:t>
+              <a:t>10/23/2026</a:t>
             </a:fld>
             <a:endParaRPr lang="en-US"/>
           </a:p>
@@ -1167,10 +1789,9 @@
           <a:lstStyle/>
           <a:p>
             <a:r>
-              <a:rPr lang="en-US" smtClean="0"/>
+              <a:rPr lang="en-US"/>
               <a:t>Click to edit Master title style</a:t>
             </a:r>
-            <a:endParaRPr lang="en-US"/>
           </a:p>
         </p:txBody>
       </p:sp>
@@ -1224,38 +1845,37 @@
           <a:p>
             <a:pPr lvl="0"/>
             <a:r>
-              <a:rPr lang="en-US" smtClean="0"/>
+              <a:rPr lang="en-US"/>
               <a:t>Click to edit Master text styles</a:t>
             </a:r>
           </a:p>
           <a:p>
             <a:pPr lvl="1"/>
             <a:r>
-              <a:rPr lang="en-US" smtClean="0"/>
+              <a:rPr lang="en-US"/>
               <a:t>Second level</a:t>
             </a:r>
           </a:p>
           <a:p>
             <a:pPr lvl="2"/>
             <a:r>
-              <a:rPr lang="en-US" smtClean="0"/>
+              <a:rPr lang="en-US"/>
               <a:t>Third level</a:t>
             </a:r>
           </a:p>
           <a:p>
             <a:pPr lvl="3"/>
             <a:r>
-              <a:rPr lang="en-US" smtClean="0"/>
+              <a:rPr lang="en-US"/>
               <a:t>Fourth level</a:t>
             </a:r>
           </a:p>
           <a:p>
             <a:pPr lvl="4"/>
             <a:r>
-              <a:rPr lang="en-US" smtClean="0"/>
+              <a:rPr lang="en-US"/>
               <a:t>Fifth level</a:t>
             </a:r>
-            <a:endParaRPr lang="en-US"/>
           </a:p>
         </p:txBody>
       </p:sp>
@@ -1309,38 +1929,37 @@
           <a:p>
             <a:pPr lvl="0"/>
             <a:r>
-              <a:rPr lang="en-US" smtClean="0"/>
+              <a:rPr lang="en-US"/>
               <a:t>Click to edit Master text styles</a:t>
             </a:r>
           </a:p>
           <a:p>
             <a:pPr lvl="1"/>
             <a:r>
-              <a:rPr lang="en-US" smtClean="0"/>
+              <a:rPr lang="en-US"/>
               <a:t>Second level</a:t>
             </a:r>
           </a:p>
           <a:p>
             <a:pPr lvl="2"/>
             <a:r>
-              <a:rPr lang="en-US" smtClean="0"/>
+              <a:rPr lang="en-US"/>
               <a:t>Third level</a:t>
             </a:r>
           </a:p>
           <a:p>
             <a:pPr lvl="3"/>
             <a:r>
-              <a:rPr lang="en-US" smtClean="0"/>
+              <a:rPr lang="en-US"/>
               <a:t>Fourth level</a:t>
             </a:r>
           </a:p>
           <a:p>
             <a:pPr lvl="4"/>
             <a:r>
-              <a:rPr lang="en-US" smtClean="0"/>
+              <a:rPr lang="en-US"/>
               <a:t>Fifth level</a:t>
             </a:r>
-            <a:endParaRPr lang="en-US"/>
           </a:p>
         </p:txBody>
       </p:sp>
@@ -1361,7 +1980,7 @@
           <a:p>
             <a:fld id="{5BCAD085-E8A6-8845-BD4E-CB4CCA059FC4}" type="datetimeFigureOut">
               <a:rPr lang="en-US" smtClean="0"/>
-              <a:t>1/27/13</a:t>
+              <a:t>10/23/2026</a:t>
             </a:fld>
             <a:endParaRPr lang="en-US"/>
           </a:p>
@@ -1459,10 +2078,9 @@
           </a:lstStyle>
           <a:p>
             <a:r>
-              <a:rPr lang="en-US" smtClean="0"/>
+              <a:rPr lang="en-US"/>
               <a:t>Click to edit Master title style</a:t>
             </a:r>
-            <a:endParaRPr lang="en-US"/>
           </a:p>
         </p:txBody>
       </p:sp>
@@ -1525,7 +2143,7 @@
           <a:p>
             <a:pPr lvl="0"/>
             <a:r>
-              <a:rPr lang="en-US" smtClean="0"/>
+              <a:rPr lang="en-US"/>
               <a:t>Click to edit Master text styles</a:t>
             </a:r>
           </a:p>
@@ -1581,38 +2199,37 @@
           <a:p>
             <a:pPr lvl="0"/>
             <a:r>
-              <a:rPr lang="en-US" smtClean="0"/>
+              <a:rPr lang="en-US"/>
               <a:t>Click to edit Master text styles</a:t>
             </a:r>
           </a:p>
           <a:p>
             <a:pPr lvl="1"/>
             <a:r>
-              <a:rPr lang="en-US" smtClean="0"/>
+              <a:rPr lang="en-US"/>
               <a:t>Second level</a:t>
             </a:r>
           </a:p>
           <a:p>
             <a:pPr lvl="2"/>
             <a:r>
-              <a:rPr lang="en-US" smtClean="0"/>
+              <a:rPr lang="en-US"/>
               <a:t>Third level</a:t>
             </a:r>
           </a:p>
           <a:p>
             <a:pPr lvl="3"/>
             <a:r>
-              <a:rPr lang="en-US" smtClean="0"/>
+              <a:rPr lang="en-US"/>
               <a:t>Fourth level</a:t>
             </a:r>
           </a:p>
           <a:p>
             <a:pPr lvl="4"/>
             <a:r>
-              <a:rPr lang="en-US" smtClean="0"/>
+              <a:rPr lang="en-US"/>
               <a:t>Fifth level</a:t>
             </a:r>
-            <a:endParaRPr lang="en-US"/>
           </a:p>
         </p:txBody>
       </p:sp>
@@ -1675,7 +2292,7 @@
           <a:p>
             <a:pPr lvl="0"/>
             <a:r>
-              <a:rPr lang="en-US" smtClean="0"/>
+              <a:rPr lang="en-US"/>
               <a:t>Click to edit Master text styles</a:t>
             </a:r>
           </a:p>
@@ -1731,38 +2348,37 @@
           <a:p>
             <a:pPr lvl="0"/>
             <a:r>
-              <a:rPr lang="en-US" smtClean="0"/>
+              <a:rPr lang="en-US"/>
               <a:t>Click to edit Master text styles</a:t>
             </a:r>
           </a:p>
           <a:p>
             <a:pPr lvl="1"/>
             <a:r>
-              <a:rPr lang="en-US" smtClean="0"/>
+              <a:rPr lang="en-US"/>
               <a:t>Second level</a:t>
             </a:r>
           </a:p>
           <a:p>
             <a:pPr lvl="2"/>
             <a:r>
-              <a:rPr lang="en-US" smtClean="0"/>
+              <a:rPr lang="en-US"/>
               <a:t>Third level</a:t>
             </a:r>
           </a:p>
           <a:p>
             <a:pPr lvl="3"/>
             <a:r>
-              <a:rPr lang="en-US" smtClean="0"/>
+              <a:rPr lang="en-US"/>
               <a:t>Fourth level</a:t>
             </a:r>
           </a:p>
           <a:p>
             <a:pPr lvl="4"/>
             <a:r>
-              <a:rPr lang="en-US" smtClean="0"/>
+              <a:rPr lang="en-US"/>
               <a:t>Fifth level</a:t>
             </a:r>
-            <a:endParaRPr lang="en-US"/>
           </a:p>
         </p:txBody>
       </p:sp>
@@ -1783,7 +2399,7 @@
           <a:p>
             <a:fld id="{5BCAD085-E8A6-8845-BD4E-CB4CCA059FC4}" type="datetimeFigureOut">
               <a:rPr lang="en-US" smtClean="0"/>
-              <a:t>1/27/13</a:t>
+              <a:t>10/23/2026</a:t>
             </a:fld>
             <a:endParaRPr lang="en-US"/>
           </a:p>
@@ -1877,10 +2493,9 @@
           <a:lstStyle/>
           <a:p>
             <a:r>
-              <a:rPr lang="en-US" smtClean="0"/>
+              <a:rPr lang="en-US"/>
               <a:t>Click to edit Master title style</a:t>
             </a:r>
-            <a:endParaRPr lang="en-US"/>
           </a:p>
         </p:txBody>
       </p:sp>
@@ -1901,7 +2516,7 @@
           <a:p>
             <a:fld id="{5BCAD085-E8A6-8845-BD4E-CB4CCA059FC4}" type="datetimeFigureOut">
               <a:rPr lang="en-US" smtClean="0"/>
-              <a:t>1/27/13</a:t>
+              <a:t>10/23/2026</a:t>
             </a:fld>
             <a:endParaRPr lang="en-US"/>
           </a:p>
@@ -1996,7 +2611,7 @@
           <a:p>
             <a:fld id="{5BCAD085-E8A6-8845-BD4E-CB4CCA059FC4}" type="datetimeFigureOut">
               <a:rPr lang="en-US" smtClean="0"/>
-              <a:t>1/27/13</a:t>
+              <a:t>10/23/2026</a:t>
             </a:fld>
             <a:endParaRPr lang="en-US"/>
           </a:p>
@@ -2099,10 +2714,9 @@
           </a:lstStyle>
           <a:p>
             <a:r>
-              <a:rPr lang="en-US" smtClean="0"/>
+              <a:rPr lang="en-US"/>
               <a:t>Click to edit Master title style</a:t>
             </a:r>
-            <a:endParaRPr lang="en-US"/>
           </a:p>
         </p:txBody>
       </p:sp>
@@ -2156,38 +2770,37 @@
           <a:p>
             <a:pPr lvl="0"/>
             <a:r>
-              <a:rPr lang="en-US" smtClean="0"/>
+              <a:rPr lang="en-US"/>
               <a:t>Click to edit Master text styles</a:t>
             </a:r>
           </a:p>
           <a:p>
             <a:pPr lvl="1"/>
             <a:r>
-              <a:rPr lang="en-US" smtClean="0"/>
+              <a:rPr lang="en-US"/>
               <a:t>Second level</a:t>
             </a:r>
           </a:p>
           <a:p>
             <a:pPr lvl="2"/>
             <a:r>
-              <a:rPr lang="en-US" smtClean="0"/>
+              <a:rPr lang="en-US"/>
               <a:t>Third level</a:t>
             </a:r>
           </a:p>
           <a:p>
             <a:pPr lvl="3"/>
             <a:r>
-              <a:rPr lang="en-US" smtClean="0"/>
+              <a:rPr lang="en-US"/>
               <a:t>Fourth level</a:t>
             </a:r>
           </a:p>
           <a:p>
             <a:pPr lvl="4"/>
             <a:r>
-              <a:rPr lang="en-US" smtClean="0"/>
+              <a:rPr lang="en-US"/>
               <a:t>Fifth level</a:t>
             </a:r>
-            <a:endParaRPr lang="en-US"/>
           </a:p>
         </p:txBody>
       </p:sp>
@@ -2250,7 +2863,7 @@
           <a:p>
             <a:pPr lvl="0"/>
             <a:r>
-              <a:rPr lang="en-US" smtClean="0"/>
+              <a:rPr lang="en-US"/>
               <a:t>Click to edit Master text styles</a:t>
             </a:r>
           </a:p>
@@ -2273,7 +2886,7 @@
           <a:p>
             <a:fld id="{5BCAD085-E8A6-8845-BD4E-CB4CCA059FC4}" type="datetimeFigureOut">
               <a:rPr lang="en-US" smtClean="0"/>
-              <a:t>1/27/13</a:t>
+              <a:t>10/23/2026</a:t>
             </a:fld>
             <a:endParaRPr lang="en-US"/>
           </a:p>
@@ -2376,10 +2989,9 @@
           </a:lstStyle>
           <a:p>
             <a:r>
-              <a:rPr lang="en-US" smtClean="0"/>
+              <a:rPr lang="en-US"/>
               <a:t>Click to edit Master title style</a:t>
             </a:r>
-            <a:endParaRPr lang="en-US"/>
           </a:p>
         </p:txBody>
       </p:sp>
@@ -2503,7 +3115,7 @@
           <a:p>
             <a:pPr lvl="0"/>
             <a:r>
-              <a:rPr lang="en-US" smtClean="0"/>
+              <a:rPr lang="en-US"/>
               <a:t>Click to edit Master text styles</a:t>
             </a:r>
           </a:p>
@@ -2526,7 +3138,7 @@
           <a:p>
             <a:fld id="{5BCAD085-E8A6-8845-BD4E-CB4CCA059FC4}" type="datetimeFigureOut">
               <a:rPr lang="en-US" smtClean="0"/>
-              <a:t>1/27/13</a:t>
+              <a:t>10/23/2026</a:t>
             </a:fld>
             <a:endParaRPr lang="en-US"/>
           </a:p>
@@ -2635,10 +3247,9 @@
           <a:lstStyle/>
           <a:p>
             <a:r>
-              <a:rPr lang="en-US" smtClean="0"/>
+              <a:rPr lang="en-US"/>
               <a:t>Click to edit Master title style</a:t>
             </a:r>
-            <a:endParaRPr lang="en-US"/>
           </a:p>
         </p:txBody>
       </p:sp>
@@ -2669,38 +3280,37 @@
           <a:p>
             <a:pPr lvl="0"/>
             <a:r>
-              <a:rPr lang="en-US" smtClean="0"/>
+              <a:rPr lang="en-US"/>
               <a:t>Click to edit Master text styles</a:t>
             </a:r>
           </a:p>
           <a:p>
             <a:pPr lvl="1"/>
             <a:r>
-              <a:rPr lang="en-US" smtClean="0"/>
+              <a:rPr lang="en-US"/>
               <a:t>Second level</a:t>
             </a:r>
           </a:p>
           <a:p>
             <a:pPr lvl="2"/>
             <a:r>
-              <a:rPr lang="en-US" smtClean="0"/>
+              <a:rPr lang="en-US"/>
               <a:t>Third level</a:t>
             </a:r>
           </a:p>
           <a:p>
             <a:pPr lvl="3"/>
             <a:r>
-              <a:rPr lang="en-US" smtClean="0"/>
+              <a:rPr lang="en-US"/>
               <a:t>Fourth level</a:t>
             </a:r>
           </a:p>
           <a:p>
             <a:pPr lvl="4"/>
             <a:r>
-              <a:rPr lang="en-US" smtClean="0"/>
+              <a:rPr lang="en-US"/>
               <a:t>Fifth level</a:t>
             </a:r>
-            <a:endParaRPr lang="en-US"/>
           </a:p>
         </p:txBody>
       </p:sp>
@@ -2739,7 +3349,7 @@
           <a:p>
             <a:fld id="{5BCAD085-E8A6-8845-BD4E-CB4CCA059FC4}" type="datetimeFigureOut">
               <a:rPr lang="en-US" smtClean="0"/>
-              <a:t>1/27/13</a:t>
+              <a:t>10/23/2026</a:t>
             </a:fld>
             <a:endParaRPr lang="en-US"/>
           </a:p>
@@ -3098,7 +3708,7 @@
 </file>
 
 <file path=ppt/slides/slide1.xml><?xml version="1.0" encoding="utf-8"?>
-<p:sld xmlns:a="http://schemas.openxmlformats.org/drawingml/2006/main" xmlns:p="http://schemas.openxmlformats.org/presentationml/2006/main" xmlns:r="http://schemas.openxmlformats.org/officeDocument/2006/relationships">
+<p:sld xmlns:a="http://schemas.openxmlformats.org/drawingml/2006/main" xmlns:r="http://schemas.openxmlformats.org/officeDocument/2006/relationships" xmlns:p="http://schemas.openxmlformats.org/presentationml/2006/main">
   <p:cSld>
     <p:bg>
       <p:bgPr>
@@ -3114,7 +3724,14 @@
         <p:cNvGrpSpPr/>
         <p:nvPr/>
       </p:nvGrpSpPr>
-      <p:grpSpPr/>
+      <p:grpSpPr>
+        <a:xfrm>
+          <a:off x="0" y="0"/>
+          <a:ext cx="0" cy="0"/>
+          <a:chOff x="0" y="0"/>
+          <a:chExt cx="0" cy="0"/>
+        </a:xfrm>
+      </p:grpSpPr>
       <p:sp>
         <p:nvSpPr>
           <p:cNvPr id="2" name="Rounded Rectangle 1"/>
@@ -3157,6 +3774,7 @@
           <a:lstStyle/>
           <a:p>
             <a:pPr algn="ctr"/>
+            <a:endParaRPr/>
           </a:p>
         </p:txBody>
       </p:sp>
@@ -3287,6 +3905,7 @@
           <a:lstStyle/>
           <a:p>
             <a:pPr algn="ctr"/>
+            <a:endParaRPr/>
           </a:p>
         </p:txBody>
       </p:sp>
@@ -3382,6 +4001,7 @@
           <a:lstStyle/>
           <a:p>
             <a:pPr algn="ctr"/>
+            <a:endParaRPr/>
           </a:p>
         </p:txBody>
       </p:sp>
@@ -3477,6 +4097,7 @@
           <a:lstStyle/>
           <a:p>
             <a:pPr algn="ctr"/>
+            <a:endParaRPr/>
           </a:p>
         </p:txBody>
       </p:sp>
@@ -3574,7 +4195,7 @@
 </file>
 
 <file path=ppt/slides/slide10.xml><?xml version="1.0" encoding="utf-8"?>
-<p:sld xmlns:a="http://schemas.openxmlformats.org/drawingml/2006/main" xmlns:p="http://schemas.openxmlformats.org/presentationml/2006/main" xmlns:r="http://schemas.openxmlformats.org/officeDocument/2006/relationships">
+<p:sld xmlns:a="http://schemas.openxmlformats.org/drawingml/2006/main" xmlns:r="http://schemas.openxmlformats.org/officeDocument/2006/relationships" xmlns:p="http://schemas.openxmlformats.org/presentationml/2006/main">
   <p:cSld>
     <p:bg>
       <p:bgPr>
@@ -3590,7 +4211,14 @@
         <p:cNvGrpSpPr/>
         <p:nvPr/>
       </p:nvGrpSpPr>
-      <p:grpSpPr/>
+      <p:grpSpPr>
+        <a:xfrm>
+          <a:off x="0" y="0"/>
+          <a:ext cx="0" cy="0"/>
+          <a:chOff x="0" y="0"/>
+          <a:chExt cx="0" cy="0"/>
+        </a:xfrm>
+      </p:grpSpPr>
       <p:sp>
         <p:nvSpPr>
           <p:cNvPr id="2" name="TextBox 1"/>
@@ -3703,6 +4331,7 @@
           <a:lstStyle/>
           <a:p>
             <a:pPr algn="ctr"/>
+            <a:endParaRPr/>
           </a:p>
         </p:txBody>
       </p:sp>
@@ -3873,6 +4502,7 @@
           <a:lstStyle/>
           <a:p>
             <a:pPr algn="ctr"/>
+            <a:endParaRPr/>
           </a:p>
         </p:txBody>
       </p:sp>
@@ -3886,14 +4516,15 @@
         </p:nvPicPr>
         <p:blipFill>
           <a:blip r:embed="rId2"/>
+          <a:srcRect/>
           <a:stretch>
             <a:fillRect/>
           </a:stretch>
         </p:blipFill>
         <p:spPr>
           <a:xfrm>
-            <a:off x="5696712" y="1444752"/>
-            <a:ext cx="5705856" cy="4425696"/>
+            <a:off x="5696712" y="1874520"/>
+            <a:ext cx="5705856" cy="3566160"/>
           </a:xfrm>
           <a:prstGeom prst="rect">
             <a:avLst/>
@@ -3944,7 +4575,7 @@
 </file>
 
 <file path=ppt/slides/slide11.xml><?xml version="1.0" encoding="utf-8"?>
-<p:sld xmlns:a="http://schemas.openxmlformats.org/drawingml/2006/main" xmlns:p="http://schemas.openxmlformats.org/presentationml/2006/main" xmlns:r="http://schemas.openxmlformats.org/officeDocument/2006/relationships">
+<p:sld xmlns:a="http://schemas.openxmlformats.org/drawingml/2006/main" xmlns:r="http://schemas.openxmlformats.org/officeDocument/2006/relationships" xmlns:p="http://schemas.openxmlformats.org/presentationml/2006/main">
   <p:cSld>
     <p:bg>
       <p:bgPr>
@@ -3960,7 +4591,14 @@
         <p:cNvGrpSpPr/>
         <p:nvPr/>
       </p:nvGrpSpPr>
-      <p:grpSpPr/>
+      <p:grpSpPr>
+        <a:xfrm>
+          <a:off x="0" y="0"/>
+          <a:ext cx="0" cy="0"/>
+          <a:chOff x="0" y="0"/>
+          <a:chExt cx="0" cy="0"/>
+        </a:xfrm>
+      </p:grpSpPr>
       <p:sp>
         <p:nvSpPr>
           <p:cNvPr id="2" name="TextBox 1"/>
@@ -4073,6 +4711,7 @@
           <a:lstStyle/>
           <a:p>
             <a:pPr algn="ctr"/>
+            <a:endParaRPr/>
           </a:p>
         </p:txBody>
       </p:sp>
@@ -4243,6 +4882,7 @@
           <a:lstStyle/>
           <a:p>
             <a:pPr algn="ctr"/>
+            <a:endParaRPr/>
           </a:p>
         </p:txBody>
       </p:sp>
@@ -4256,14 +4896,15 @@
         </p:nvPicPr>
         <p:blipFill>
           <a:blip r:embed="rId2"/>
+          <a:srcRect/>
           <a:stretch>
             <a:fillRect/>
           </a:stretch>
         </p:blipFill>
         <p:spPr>
           <a:xfrm>
-            <a:off x="5696712" y="1444752"/>
-            <a:ext cx="5705856" cy="4425696"/>
+            <a:off x="5696712" y="2543175"/>
+            <a:ext cx="5705856" cy="2228850"/>
           </a:xfrm>
           <a:prstGeom prst="rect">
             <a:avLst/>
@@ -4314,7 +4955,7 @@
 </file>
 
 <file path=ppt/slides/slide12.xml><?xml version="1.0" encoding="utf-8"?>
-<p:sld xmlns:a="http://schemas.openxmlformats.org/drawingml/2006/main" xmlns:p="http://schemas.openxmlformats.org/presentationml/2006/main" xmlns:r="http://schemas.openxmlformats.org/officeDocument/2006/relationships">
+<p:sld xmlns:a="http://schemas.openxmlformats.org/drawingml/2006/main" xmlns:r="http://schemas.openxmlformats.org/officeDocument/2006/relationships" xmlns:p="http://schemas.openxmlformats.org/presentationml/2006/main">
   <p:cSld>
     <p:bg>
       <p:bgPr>
@@ -4330,7 +4971,14 @@
         <p:cNvGrpSpPr/>
         <p:nvPr/>
       </p:nvGrpSpPr>
-      <p:grpSpPr/>
+      <p:grpSpPr>
+        <a:xfrm>
+          <a:off x="0" y="0"/>
+          <a:ext cx="0" cy="0"/>
+          <a:chOff x="0" y="0"/>
+          <a:chExt cx="0" cy="0"/>
+        </a:xfrm>
+      </p:grpSpPr>
       <p:sp>
         <p:nvSpPr>
           <p:cNvPr id="2" name="TextBox 1"/>
@@ -4443,6 +5091,7 @@
           <a:lstStyle/>
           <a:p>
             <a:pPr algn="ctr"/>
+            <a:endParaRPr/>
           </a:p>
         </p:txBody>
       </p:sp>
@@ -4613,6 +5262,7 @@
           <a:lstStyle/>
           <a:p>
             <a:pPr algn="ctr"/>
+            <a:endParaRPr/>
           </a:p>
         </p:txBody>
       </p:sp>
@@ -4626,14 +5276,15 @@
         </p:nvPicPr>
         <p:blipFill>
           <a:blip r:embed="rId2"/>
+          <a:srcRect/>
           <a:stretch>
             <a:fillRect/>
           </a:stretch>
         </p:blipFill>
         <p:spPr>
           <a:xfrm>
-            <a:off x="5696712" y="1444752"/>
-            <a:ext cx="5705856" cy="4425696"/>
+            <a:off x="5696712" y="1874520"/>
+            <a:ext cx="5705856" cy="3566160"/>
           </a:xfrm>
           <a:prstGeom prst="rect">
             <a:avLst/>
@@ -4684,7 +5335,7 @@
 </file>
 
 <file path=ppt/slides/slide13.xml><?xml version="1.0" encoding="utf-8"?>
-<p:sld xmlns:a="http://schemas.openxmlformats.org/drawingml/2006/main" xmlns:p="http://schemas.openxmlformats.org/presentationml/2006/main" xmlns:r="http://schemas.openxmlformats.org/officeDocument/2006/relationships">
+<p:sld xmlns:a="http://schemas.openxmlformats.org/drawingml/2006/main" xmlns:r="http://schemas.openxmlformats.org/officeDocument/2006/relationships" xmlns:p="http://schemas.openxmlformats.org/presentationml/2006/main">
   <p:cSld>
     <p:bg>
       <p:bgPr>
@@ -4700,7 +5351,14 @@
         <p:cNvGrpSpPr/>
         <p:nvPr/>
       </p:nvGrpSpPr>
-      <p:grpSpPr/>
+      <p:grpSpPr>
+        <a:xfrm>
+          <a:off x="0" y="0"/>
+          <a:ext cx="0" cy="0"/>
+          <a:chOff x="0" y="0"/>
+          <a:chExt cx="0" cy="0"/>
+        </a:xfrm>
+      </p:grpSpPr>
       <p:sp>
         <p:nvSpPr>
           <p:cNvPr id="2" name="TextBox 1"/>
@@ -4813,6 +5471,7 @@
           <a:lstStyle/>
           <a:p>
             <a:pPr algn="ctr"/>
+            <a:endParaRPr/>
           </a:p>
         </p:txBody>
       </p:sp>
@@ -4983,6 +5642,7 @@
           <a:lstStyle/>
           <a:p>
             <a:pPr algn="ctr"/>
+            <a:endParaRPr/>
           </a:p>
         </p:txBody>
       </p:sp>
@@ -4995,15 +5655,16 @@
           <p:nvPr/>
         </p:nvPicPr>
         <p:blipFill>
-          <a:blip r:embed="rId2"/>
+          <a:blip r:embed="rId3"/>
+          <a:srcRect/>
           <a:stretch>
             <a:fillRect/>
           </a:stretch>
         </p:blipFill>
         <p:spPr>
           <a:xfrm>
-            <a:off x="5696712" y="1444752"/>
-            <a:ext cx="5705856" cy="4425696"/>
+            <a:off x="5685137" y="1909245"/>
+            <a:ext cx="5705856" cy="3566160"/>
           </a:xfrm>
           <a:prstGeom prst="rect">
             <a:avLst/>
@@ -5054,7 +5715,7 @@
 </file>
 
 <file path=ppt/slides/slide14.xml><?xml version="1.0" encoding="utf-8"?>
-<p:sld xmlns:a="http://schemas.openxmlformats.org/drawingml/2006/main" xmlns:p="http://schemas.openxmlformats.org/presentationml/2006/main" xmlns:r="http://schemas.openxmlformats.org/officeDocument/2006/relationships">
+<p:sld xmlns:a="http://schemas.openxmlformats.org/drawingml/2006/main" xmlns:r="http://schemas.openxmlformats.org/officeDocument/2006/relationships" xmlns:p="http://schemas.openxmlformats.org/presentationml/2006/main">
   <p:cSld>
     <p:bg>
       <p:bgPr>
@@ -5070,7 +5731,14 @@
         <p:cNvGrpSpPr/>
         <p:nvPr/>
       </p:nvGrpSpPr>
-      <p:grpSpPr/>
+      <p:grpSpPr>
+        <a:xfrm>
+          <a:off x="0" y="0"/>
+          <a:ext cx="0" cy="0"/>
+          <a:chOff x="0" y="0"/>
+          <a:chExt cx="0" cy="0"/>
+        </a:xfrm>
+      </p:grpSpPr>
       <p:sp>
         <p:nvSpPr>
           <p:cNvPr id="2" name="TextBox 1"/>
@@ -5183,6 +5851,7 @@
           <a:lstStyle/>
           <a:p>
             <a:pPr algn="ctr"/>
+            <a:endParaRPr/>
           </a:p>
         </p:txBody>
       </p:sp>
@@ -5353,6 +6022,7 @@
           <a:lstStyle/>
           <a:p>
             <a:pPr algn="ctr"/>
+            <a:endParaRPr/>
           </a:p>
         </p:txBody>
       </p:sp>
@@ -5366,14 +6036,15 @@
         </p:nvPicPr>
         <p:blipFill>
           <a:blip r:embed="rId2"/>
+          <a:srcRect/>
           <a:stretch>
             <a:fillRect/>
           </a:stretch>
         </p:blipFill>
         <p:spPr>
           <a:xfrm>
-            <a:off x="5696712" y="1444752"/>
-            <a:ext cx="5705856" cy="4425696"/>
+            <a:off x="5696712" y="1874520"/>
+            <a:ext cx="5705856" cy="3566160"/>
           </a:xfrm>
           <a:prstGeom prst="rect">
             <a:avLst/>
@@ -5424,7 +6095,7 @@
 </file>
 
 <file path=ppt/slides/slide15.xml><?xml version="1.0" encoding="utf-8"?>
-<p:sld xmlns:a="http://schemas.openxmlformats.org/drawingml/2006/main" xmlns:p="http://schemas.openxmlformats.org/presentationml/2006/main" xmlns:r="http://schemas.openxmlformats.org/officeDocument/2006/relationships">
+<p:sld xmlns:a="http://schemas.openxmlformats.org/drawingml/2006/main" xmlns:r="http://schemas.openxmlformats.org/officeDocument/2006/relationships" xmlns:p="http://schemas.openxmlformats.org/presentationml/2006/main">
   <p:cSld>
     <p:bg>
       <p:bgPr>
@@ -5440,7 +6111,14 @@
         <p:cNvGrpSpPr/>
         <p:nvPr/>
       </p:nvGrpSpPr>
-      <p:grpSpPr/>
+      <p:grpSpPr>
+        <a:xfrm>
+          <a:off x="0" y="0"/>
+          <a:ext cx="0" cy="0"/>
+          <a:chOff x="0" y="0"/>
+          <a:chExt cx="0" cy="0"/>
+        </a:xfrm>
+      </p:grpSpPr>
       <p:sp>
         <p:nvSpPr>
           <p:cNvPr id="2" name="TextBox 1"/>
@@ -5553,6 +6231,7 @@
           <a:lstStyle/>
           <a:p>
             <a:pPr algn="ctr"/>
+            <a:endParaRPr/>
           </a:p>
         </p:txBody>
       </p:sp>
@@ -5723,6 +6402,7 @@
           <a:lstStyle/>
           <a:p>
             <a:pPr algn="ctr"/>
+            <a:endParaRPr/>
           </a:p>
         </p:txBody>
       </p:sp>
@@ -5736,14 +6416,15 @@
         </p:nvPicPr>
         <p:blipFill>
           <a:blip r:embed="rId2"/>
+          <a:srcRect/>
           <a:stretch>
             <a:fillRect/>
           </a:stretch>
         </p:blipFill>
         <p:spPr>
           <a:xfrm>
-            <a:off x="5696712" y="1444752"/>
-            <a:ext cx="5705856" cy="4425696"/>
+            <a:off x="5696712" y="1874520"/>
+            <a:ext cx="5705856" cy="3566160"/>
           </a:xfrm>
           <a:prstGeom prst="rect">
             <a:avLst/>
@@ -5794,7 +6475,7 @@
 </file>
 
 <file path=ppt/slides/slide16.xml><?xml version="1.0" encoding="utf-8"?>
-<p:sld xmlns:a="http://schemas.openxmlformats.org/drawingml/2006/main" xmlns:p="http://schemas.openxmlformats.org/presentationml/2006/main" xmlns:r="http://schemas.openxmlformats.org/officeDocument/2006/relationships">
+<p:sld xmlns:a="http://schemas.openxmlformats.org/drawingml/2006/main" xmlns:r="http://schemas.openxmlformats.org/officeDocument/2006/relationships" xmlns:p="http://schemas.openxmlformats.org/presentationml/2006/main">
   <p:cSld>
     <p:bg>
       <p:bgPr>
@@ -5810,7 +6491,14 @@
         <p:cNvGrpSpPr/>
         <p:nvPr/>
       </p:nvGrpSpPr>
-      <p:grpSpPr/>
+      <p:grpSpPr>
+        <a:xfrm>
+          <a:off x="0" y="0"/>
+          <a:ext cx="0" cy="0"/>
+          <a:chOff x="0" y="0"/>
+          <a:chExt cx="0" cy="0"/>
+        </a:xfrm>
+      </p:grpSpPr>
       <p:sp>
         <p:nvSpPr>
           <p:cNvPr id="2" name="TextBox 1"/>
@@ -5923,6 +6611,7 @@
           <a:lstStyle/>
           <a:p>
             <a:pPr algn="ctr"/>
+            <a:endParaRPr/>
           </a:p>
         </p:txBody>
       </p:sp>
@@ -6093,6 +6782,7 @@
           <a:lstStyle/>
           <a:p>
             <a:pPr algn="ctr"/>
+            <a:endParaRPr/>
           </a:p>
         </p:txBody>
       </p:sp>
@@ -6106,14 +6796,15 @@
         </p:nvPicPr>
         <p:blipFill>
           <a:blip r:embed="rId2"/>
+          <a:srcRect/>
           <a:stretch>
             <a:fillRect/>
           </a:stretch>
         </p:blipFill>
         <p:spPr>
           <a:xfrm>
-            <a:off x="5696712" y="1444752"/>
-            <a:ext cx="5705856" cy="4425696"/>
+            <a:off x="5696712" y="1874520"/>
+            <a:ext cx="5705856" cy="3566160"/>
           </a:xfrm>
           <a:prstGeom prst="rect">
             <a:avLst/>
@@ -6164,7 +6855,7 @@
 </file>
 
 <file path=ppt/slides/slide17.xml><?xml version="1.0" encoding="utf-8"?>
-<p:sld xmlns:a="http://schemas.openxmlformats.org/drawingml/2006/main" xmlns:p="http://schemas.openxmlformats.org/presentationml/2006/main" xmlns:r="http://schemas.openxmlformats.org/officeDocument/2006/relationships">
+<p:sld xmlns:a="http://schemas.openxmlformats.org/drawingml/2006/main" xmlns:r="http://schemas.openxmlformats.org/officeDocument/2006/relationships" xmlns:p="http://schemas.openxmlformats.org/presentationml/2006/main">
   <p:cSld>
     <p:bg>
       <p:bgPr>
@@ -6180,7 +6871,14 @@
         <p:cNvGrpSpPr/>
         <p:nvPr/>
       </p:nvGrpSpPr>
-      <p:grpSpPr/>
+      <p:grpSpPr>
+        <a:xfrm>
+          <a:off x="0" y="0"/>
+          <a:ext cx="0" cy="0"/>
+          <a:chOff x="0" y="0"/>
+          <a:chExt cx="0" cy="0"/>
+        </a:xfrm>
+      </p:grpSpPr>
       <p:sp>
         <p:nvSpPr>
           <p:cNvPr id="2" name="TextBox 1"/>
@@ -6270,10 +6968,34 @@
                 <a:tableStyleId>{5C22544A-7EE6-4342-B048-85BDC9FD1C3A}</a:tableStyleId>
               </a:tblPr>
               <a:tblGrid>
-                <a:gridCol w="1828800"/>
-                <a:gridCol w="4114800"/>
-                <a:gridCol w="2011680"/>
-                <a:gridCol w="2743200"/>
+                <a:gridCol w="1828800">
+                  <a:extLst>
+                    <a:ext uri="{9D8B030D-6E8A-4147-A177-3AD203B41FA5}">
+                      <a16:colId xmlns:a16="http://schemas.microsoft.com/office/drawing/2014/main" val="20000"/>
+                    </a:ext>
+                  </a:extLst>
+                </a:gridCol>
+                <a:gridCol w="4114800">
+                  <a:extLst>
+                    <a:ext uri="{9D8B030D-6E8A-4147-A177-3AD203B41FA5}">
+                      <a16:colId xmlns:a16="http://schemas.microsoft.com/office/drawing/2014/main" val="20001"/>
+                    </a:ext>
+                  </a:extLst>
+                </a:gridCol>
+                <a:gridCol w="2011680">
+                  <a:extLst>
+                    <a:ext uri="{9D8B030D-6E8A-4147-A177-3AD203B41FA5}">
+                      <a16:colId xmlns:a16="http://schemas.microsoft.com/office/drawing/2014/main" val="20002"/>
+                    </a:ext>
+                  </a:extLst>
+                </a:gridCol>
+                <a:gridCol w="2743200">
+                  <a:extLst>
+                    <a:ext uri="{9D8B030D-6E8A-4147-A177-3AD203B41FA5}">
+                      <a16:colId xmlns:a16="http://schemas.microsoft.com/office/drawing/2014/main" val="20003"/>
+                    </a:ext>
+                  </a:extLst>
+                </a:gridCol>
               </a:tblGrid>
               <a:tr h="418011">
                 <a:tc>
@@ -6368,6 +7090,11 @@
                     </a:solidFill>
                   </a:tcPr>
                 </a:tc>
+                <a:extLst>
+                  <a:ext uri="{0D108BD9-81ED-4DB2-BD59-A6C34878D82A}">
+                    <a16:rowId xmlns:a16="http://schemas.microsoft.com/office/drawing/2014/main" val="10000"/>
+                  </a:ext>
+                </a:extLst>
               </a:tr>
               <a:tr h="418011">
                 <a:tc>
@@ -6462,6 +7189,11 @@
                     </a:solidFill>
                   </a:tcPr>
                 </a:tc>
+                <a:extLst>
+                  <a:ext uri="{0D108BD9-81ED-4DB2-BD59-A6C34878D82A}">
+                    <a16:rowId xmlns:a16="http://schemas.microsoft.com/office/drawing/2014/main" val="10001"/>
+                  </a:ext>
+                </a:extLst>
               </a:tr>
               <a:tr h="418011">
                 <a:tc>
@@ -6556,6 +7288,11 @@
                     </a:solidFill>
                   </a:tcPr>
                 </a:tc>
+                <a:extLst>
+                  <a:ext uri="{0D108BD9-81ED-4DB2-BD59-A6C34878D82A}">
+                    <a16:rowId xmlns:a16="http://schemas.microsoft.com/office/drawing/2014/main" val="10002"/>
+                  </a:ext>
+                </a:extLst>
               </a:tr>
               <a:tr h="418011">
                 <a:tc>
@@ -6650,6 +7387,11 @@
                     </a:solidFill>
                   </a:tcPr>
                 </a:tc>
+                <a:extLst>
+                  <a:ext uri="{0D108BD9-81ED-4DB2-BD59-A6C34878D82A}">
+                    <a16:rowId xmlns:a16="http://schemas.microsoft.com/office/drawing/2014/main" val="10003"/>
+                  </a:ext>
+                </a:extLst>
               </a:tr>
               <a:tr h="418011">
                 <a:tc>
@@ -6744,6 +7486,11 @@
                     </a:solidFill>
                   </a:tcPr>
                 </a:tc>
+                <a:extLst>
+                  <a:ext uri="{0D108BD9-81ED-4DB2-BD59-A6C34878D82A}">
+                    <a16:rowId xmlns:a16="http://schemas.microsoft.com/office/drawing/2014/main" val="10004"/>
+                  </a:ext>
+                </a:extLst>
               </a:tr>
               <a:tr h="418011">
                 <a:tc>
@@ -6838,6 +7585,11 @@
                     </a:solidFill>
                   </a:tcPr>
                 </a:tc>
+                <a:extLst>
+                  <a:ext uri="{0D108BD9-81ED-4DB2-BD59-A6C34878D82A}">
+                    <a16:rowId xmlns:a16="http://schemas.microsoft.com/office/drawing/2014/main" val="10005"/>
+                  </a:ext>
+                </a:extLst>
               </a:tr>
               <a:tr h="418014">
                 <a:tc>
@@ -6932,6 +7684,11 @@
                     </a:solidFill>
                   </a:tcPr>
                 </a:tc>
+                <a:extLst>
+                  <a:ext uri="{0D108BD9-81ED-4DB2-BD59-A6C34878D82A}">
+                    <a16:rowId xmlns:a16="http://schemas.microsoft.com/office/drawing/2014/main" val="10006"/>
+                  </a:ext>
+                </a:extLst>
               </a:tr>
             </a:tbl>
           </a:graphicData>
@@ -6981,7 +7738,7 @@
 </file>
 
 <file path=ppt/slides/slide18.xml><?xml version="1.0" encoding="utf-8"?>
-<p:sld xmlns:a="http://schemas.openxmlformats.org/drawingml/2006/main" xmlns:p="http://schemas.openxmlformats.org/presentationml/2006/main" xmlns:r="http://schemas.openxmlformats.org/officeDocument/2006/relationships">
+<p:sld xmlns:a="http://schemas.openxmlformats.org/drawingml/2006/main" xmlns:r="http://schemas.openxmlformats.org/officeDocument/2006/relationships" xmlns:p="http://schemas.openxmlformats.org/presentationml/2006/main">
   <p:cSld>
     <p:bg>
       <p:bgPr>
@@ -6997,7 +7754,14 @@
         <p:cNvGrpSpPr/>
         <p:nvPr/>
       </p:nvGrpSpPr>
-      <p:grpSpPr/>
+      <p:grpSpPr>
+        <a:xfrm>
+          <a:off x="0" y="0"/>
+          <a:ext cx="0" cy="0"/>
+          <a:chOff x="0" y="0"/>
+          <a:chExt cx="0" cy="0"/>
+        </a:xfrm>
+      </p:grpSpPr>
       <p:sp>
         <p:nvSpPr>
           <p:cNvPr id="2" name="TextBox 1"/>
@@ -7087,10 +7851,34 @@
                 <a:tableStyleId>{5C22544A-7EE6-4342-B048-85BDC9FD1C3A}</a:tableStyleId>
               </a:tblPr>
               <a:tblGrid>
-                <a:gridCol w="1828800"/>
-                <a:gridCol w="3474720"/>
-                <a:gridCol w="3657600"/>
-                <a:gridCol w="1737360"/>
+                <a:gridCol w="1828800">
+                  <a:extLst>
+                    <a:ext uri="{9D8B030D-6E8A-4147-A177-3AD203B41FA5}">
+                      <a16:colId xmlns:a16="http://schemas.microsoft.com/office/drawing/2014/main" val="20000"/>
+                    </a:ext>
+                  </a:extLst>
+                </a:gridCol>
+                <a:gridCol w="3474720">
+                  <a:extLst>
+                    <a:ext uri="{9D8B030D-6E8A-4147-A177-3AD203B41FA5}">
+                      <a16:colId xmlns:a16="http://schemas.microsoft.com/office/drawing/2014/main" val="20001"/>
+                    </a:ext>
+                  </a:extLst>
+                </a:gridCol>
+                <a:gridCol w="3657600">
+                  <a:extLst>
+                    <a:ext uri="{9D8B030D-6E8A-4147-A177-3AD203B41FA5}">
+                      <a16:colId xmlns:a16="http://schemas.microsoft.com/office/drawing/2014/main" val="20002"/>
+                    </a:ext>
+                  </a:extLst>
+                </a:gridCol>
+                <a:gridCol w="1737360">
+                  <a:extLst>
+                    <a:ext uri="{9D8B030D-6E8A-4147-A177-3AD203B41FA5}">
+                      <a16:colId xmlns:a16="http://schemas.microsoft.com/office/drawing/2014/main" val="20003"/>
+                    </a:ext>
+                  </a:extLst>
+                </a:gridCol>
               </a:tblGrid>
               <a:tr h="419100">
                 <a:tc>
@@ -7185,6 +7973,11 @@
                     </a:solidFill>
                   </a:tcPr>
                 </a:tc>
+                <a:extLst>
+                  <a:ext uri="{0D108BD9-81ED-4DB2-BD59-A6C34878D82A}">
+                    <a16:rowId xmlns:a16="http://schemas.microsoft.com/office/drawing/2014/main" val="10000"/>
+                  </a:ext>
+                </a:extLst>
               </a:tr>
               <a:tr h="419100">
                 <a:tc>
@@ -7279,6 +8072,11 @@
                     </a:solidFill>
                   </a:tcPr>
                 </a:tc>
+                <a:extLst>
+                  <a:ext uri="{0D108BD9-81ED-4DB2-BD59-A6C34878D82A}">
+                    <a16:rowId xmlns:a16="http://schemas.microsoft.com/office/drawing/2014/main" val="10001"/>
+                  </a:ext>
+                </a:extLst>
               </a:tr>
               <a:tr h="419100">
                 <a:tc>
@@ -7373,6 +8171,11 @@
                     </a:solidFill>
                   </a:tcPr>
                 </a:tc>
+                <a:extLst>
+                  <a:ext uri="{0D108BD9-81ED-4DB2-BD59-A6C34878D82A}">
+                    <a16:rowId xmlns:a16="http://schemas.microsoft.com/office/drawing/2014/main" val="10002"/>
+                  </a:ext>
+                </a:extLst>
               </a:tr>
               <a:tr h="419100">
                 <a:tc>
@@ -7467,6 +8270,11 @@
                     </a:solidFill>
                   </a:tcPr>
                 </a:tc>
+                <a:extLst>
+                  <a:ext uri="{0D108BD9-81ED-4DB2-BD59-A6C34878D82A}">
+                    <a16:rowId xmlns:a16="http://schemas.microsoft.com/office/drawing/2014/main" val="10003"/>
+                  </a:ext>
+                </a:extLst>
               </a:tr>
               <a:tr h="419100">
                 <a:tc>
@@ -7561,6 +8369,11 @@
                     </a:solidFill>
                   </a:tcPr>
                 </a:tc>
+                <a:extLst>
+                  <a:ext uri="{0D108BD9-81ED-4DB2-BD59-A6C34878D82A}">
+                    <a16:rowId xmlns:a16="http://schemas.microsoft.com/office/drawing/2014/main" val="10004"/>
+                  </a:ext>
+                </a:extLst>
               </a:tr>
               <a:tr h="419100">
                 <a:tc>
@@ -7655,6 +8468,11 @@
                     </a:solidFill>
                   </a:tcPr>
                 </a:tc>
+                <a:extLst>
+                  <a:ext uri="{0D108BD9-81ED-4DB2-BD59-A6C34878D82A}">
+                    <a16:rowId xmlns:a16="http://schemas.microsoft.com/office/drawing/2014/main" val="10005"/>
+                  </a:ext>
+                </a:extLst>
               </a:tr>
             </a:tbl>
           </a:graphicData>
@@ -7704,7 +8522,7 @@
 </file>
 
 <file path=ppt/slides/slide19.xml><?xml version="1.0" encoding="utf-8"?>
-<p:sld xmlns:a="http://schemas.openxmlformats.org/drawingml/2006/main" xmlns:p="http://schemas.openxmlformats.org/presentationml/2006/main" xmlns:r="http://schemas.openxmlformats.org/officeDocument/2006/relationships">
+<p:sld xmlns:a="http://schemas.openxmlformats.org/drawingml/2006/main" xmlns:r="http://schemas.openxmlformats.org/officeDocument/2006/relationships" xmlns:p="http://schemas.openxmlformats.org/presentationml/2006/main">
   <p:cSld>
     <p:bg>
       <p:bgPr>
@@ -7720,7 +8538,14 @@
         <p:cNvGrpSpPr/>
         <p:nvPr/>
       </p:nvGrpSpPr>
-      <p:grpSpPr/>
+      <p:grpSpPr>
+        <a:xfrm>
+          <a:off x="0" y="0"/>
+          <a:ext cx="0" cy="0"/>
+          <a:chOff x="0" y="0"/>
+          <a:chExt cx="0" cy="0"/>
+        </a:xfrm>
+      </p:grpSpPr>
       <p:sp>
         <p:nvSpPr>
           <p:cNvPr id="2" name="TextBox 1"/>
@@ -7810,11 +8635,41 @@
                 <a:tableStyleId>{5C22544A-7EE6-4342-B048-85BDC9FD1C3A}</a:tableStyleId>
               </a:tblPr>
               <a:tblGrid>
-                <a:gridCol w="2194560"/>
-                <a:gridCol w="2286000"/>
-                <a:gridCol w="2011680"/>
-                <a:gridCol w="2011680"/>
-                <a:gridCol w="2194560"/>
+                <a:gridCol w="2194560">
+                  <a:extLst>
+                    <a:ext uri="{9D8B030D-6E8A-4147-A177-3AD203B41FA5}">
+                      <a16:colId xmlns:a16="http://schemas.microsoft.com/office/drawing/2014/main" val="20000"/>
+                    </a:ext>
+                  </a:extLst>
+                </a:gridCol>
+                <a:gridCol w="2286000">
+                  <a:extLst>
+                    <a:ext uri="{9D8B030D-6E8A-4147-A177-3AD203B41FA5}">
+                      <a16:colId xmlns:a16="http://schemas.microsoft.com/office/drawing/2014/main" val="20001"/>
+                    </a:ext>
+                  </a:extLst>
+                </a:gridCol>
+                <a:gridCol w="2011680">
+                  <a:extLst>
+                    <a:ext uri="{9D8B030D-6E8A-4147-A177-3AD203B41FA5}">
+                      <a16:colId xmlns:a16="http://schemas.microsoft.com/office/drawing/2014/main" val="20002"/>
+                    </a:ext>
+                  </a:extLst>
+                </a:gridCol>
+                <a:gridCol w="2011680">
+                  <a:extLst>
+                    <a:ext uri="{9D8B030D-6E8A-4147-A177-3AD203B41FA5}">
+                      <a16:colId xmlns:a16="http://schemas.microsoft.com/office/drawing/2014/main" val="20003"/>
+                    </a:ext>
+                  </a:extLst>
+                </a:gridCol>
+                <a:gridCol w="2194560">
+                  <a:extLst>
+                    <a:ext uri="{9D8B030D-6E8A-4147-A177-3AD203B41FA5}">
+                      <a16:colId xmlns:a16="http://schemas.microsoft.com/office/drawing/2014/main" val="20004"/>
+                    </a:ext>
+                  </a:extLst>
+                </a:gridCol>
               </a:tblGrid>
               <a:tr h="417195">
                 <a:tc>
@@ -7932,6 +8787,11 @@
                     </a:solidFill>
                   </a:tcPr>
                 </a:tc>
+                <a:extLst>
+                  <a:ext uri="{0D108BD9-81ED-4DB2-BD59-A6C34878D82A}">
+                    <a16:rowId xmlns:a16="http://schemas.microsoft.com/office/drawing/2014/main" val="10000"/>
+                  </a:ext>
+                </a:extLst>
               </a:tr>
               <a:tr h="417195">
                 <a:tc>
@@ -8049,6 +8909,11 @@
                     </a:solidFill>
                   </a:tcPr>
                 </a:tc>
+                <a:extLst>
+                  <a:ext uri="{0D108BD9-81ED-4DB2-BD59-A6C34878D82A}">
+                    <a16:rowId xmlns:a16="http://schemas.microsoft.com/office/drawing/2014/main" val="10001"/>
+                  </a:ext>
+                </a:extLst>
               </a:tr>
               <a:tr h="417195">
                 <a:tc>
@@ -8166,6 +9031,11 @@
                     </a:solidFill>
                   </a:tcPr>
                 </a:tc>
+                <a:extLst>
+                  <a:ext uri="{0D108BD9-81ED-4DB2-BD59-A6C34878D82A}">
+                    <a16:rowId xmlns:a16="http://schemas.microsoft.com/office/drawing/2014/main" val="10002"/>
+                  </a:ext>
+                </a:extLst>
               </a:tr>
               <a:tr h="417195">
                 <a:tc>
@@ -8283,6 +9153,11 @@
                     </a:solidFill>
                   </a:tcPr>
                 </a:tc>
+                <a:extLst>
+                  <a:ext uri="{0D108BD9-81ED-4DB2-BD59-A6C34878D82A}">
+                    <a16:rowId xmlns:a16="http://schemas.microsoft.com/office/drawing/2014/main" val="10003"/>
+                  </a:ext>
+                </a:extLst>
               </a:tr>
               <a:tr h="417195">
                 <a:tc>
@@ -8400,6 +9275,11 @@
                     </a:solidFill>
                   </a:tcPr>
                 </a:tc>
+                <a:extLst>
+                  <a:ext uri="{0D108BD9-81ED-4DB2-BD59-A6C34878D82A}">
+                    <a16:rowId xmlns:a16="http://schemas.microsoft.com/office/drawing/2014/main" val="10004"/>
+                  </a:ext>
+                </a:extLst>
               </a:tr>
               <a:tr h="417195">
                 <a:tc>
@@ -8517,6 +9397,11 @@
                     </a:solidFill>
                   </a:tcPr>
                 </a:tc>
+                <a:extLst>
+                  <a:ext uri="{0D108BD9-81ED-4DB2-BD59-A6C34878D82A}">
+                    <a16:rowId xmlns:a16="http://schemas.microsoft.com/office/drawing/2014/main" val="10005"/>
+                  </a:ext>
+                </a:extLst>
               </a:tr>
               <a:tr h="417195">
                 <a:tc>
@@ -8634,6 +9519,11 @@
                     </a:solidFill>
                   </a:tcPr>
                 </a:tc>
+                <a:extLst>
+                  <a:ext uri="{0D108BD9-81ED-4DB2-BD59-A6C34878D82A}">
+                    <a16:rowId xmlns:a16="http://schemas.microsoft.com/office/drawing/2014/main" val="10006"/>
+                  </a:ext>
+                </a:extLst>
               </a:tr>
               <a:tr h="417195">
                 <a:tc>
@@ -8751,6 +9641,11 @@
                     </a:solidFill>
                   </a:tcPr>
                 </a:tc>
+                <a:extLst>
+                  <a:ext uri="{0D108BD9-81ED-4DB2-BD59-A6C34878D82A}">
+                    <a16:rowId xmlns:a16="http://schemas.microsoft.com/office/drawing/2014/main" val="10007"/>
+                  </a:ext>
+                </a:extLst>
               </a:tr>
             </a:tbl>
           </a:graphicData>
@@ -8800,7 +9695,7 @@
 </file>
 
 <file path=ppt/slides/slide2.xml><?xml version="1.0" encoding="utf-8"?>
-<p:sld xmlns:a="http://schemas.openxmlformats.org/drawingml/2006/main" xmlns:p="http://schemas.openxmlformats.org/presentationml/2006/main" xmlns:r="http://schemas.openxmlformats.org/officeDocument/2006/relationships">
+<p:sld xmlns:a="http://schemas.openxmlformats.org/drawingml/2006/main" xmlns:r="http://schemas.openxmlformats.org/officeDocument/2006/relationships" xmlns:p="http://schemas.openxmlformats.org/presentationml/2006/main">
   <p:cSld>
     <p:bg>
       <p:bgPr>
@@ -8816,7 +9711,14 @@
         <p:cNvGrpSpPr/>
         <p:nvPr/>
       </p:nvGrpSpPr>
-      <p:grpSpPr/>
+      <p:grpSpPr>
+        <a:xfrm>
+          <a:off x="0" y="0"/>
+          <a:ext cx="0" cy="0"/>
+          <a:chOff x="0" y="0"/>
+          <a:chExt cx="0" cy="0"/>
+        </a:xfrm>
+      </p:grpSpPr>
       <p:sp>
         <p:nvSpPr>
           <p:cNvPr id="2" name="TextBox 1"/>
@@ -8929,6 +9831,7 @@
           <a:lstStyle/>
           <a:p>
             <a:pPr algn="ctr"/>
+            <a:endParaRPr/>
           </a:p>
         </p:txBody>
       </p:sp>
@@ -9069,6 +9972,7 @@
           <a:lstStyle/>
           <a:p>
             <a:pPr algn="ctr"/>
+            <a:endParaRPr/>
           </a:p>
         </p:txBody>
       </p:sp>
@@ -9209,6 +10113,7 @@
           <a:lstStyle/>
           <a:p>
             <a:pPr algn="ctr"/>
+            <a:endParaRPr/>
           </a:p>
         </p:txBody>
       </p:sp>
@@ -9316,7 +10221,7 @@
 </file>
 
 <file path=ppt/slides/slide20.xml><?xml version="1.0" encoding="utf-8"?>
-<p:sld xmlns:a="http://schemas.openxmlformats.org/drawingml/2006/main" xmlns:p="http://schemas.openxmlformats.org/presentationml/2006/main" xmlns:r="http://schemas.openxmlformats.org/officeDocument/2006/relationships">
+<p:sld xmlns:a="http://schemas.openxmlformats.org/drawingml/2006/main" xmlns:r="http://schemas.openxmlformats.org/officeDocument/2006/relationships" xmlns:p="http://schemas.openxmlformats.org/presentationml/2006/main">
   <p:cSld>
     <p:bg>
       <p:bgPr>
@@ -9332,7 +10237,14 @@
         <p:cNvGrpSpPr/>
         <p:nvPr/>
       </p:nvGrpSpPr>
-      <p:grpSpPr/>
+      <p:grpSpPr>
+        <a:xfrm>
+          <a:off x="0" y="0"/>
+          <a:ext cx="0" cy="0"/>
+          <a:chOff x="0" y="0"/>
+          <a:chExt cx="0" cy="0"/>
+        </a:xfrm>
+      </p:grpSpPr>
       <p:sp>
         <p:nvSpPr>
           <p:cNvPr id="2" name="TextBox 1"/>
@@ -9445,6 +10357,7 @@
           <a:lstStyle/>
           <a:p>
             <a:pPr algn="ctr"/>
+            <a:endParaRPr/>
           </a:p>
         </p:txBody>
       </p:sp>
@@ -9540,6 +10453,7 @@
           <a:lstStyle/>
           <a:p>
             <a:pPr algn="ctr"/>
+            <a:endParaRPr/>
           </a:p>
         </p:txBody>
       </p:sp>
@@ -9635,6 +10549,7 @@
           <a:lstStyle/>
           <a:p>
             <a:pPr algn="ctr"/>
+            <a:endParaRPr/>
           </a:p>
         </p:txBody>
       </p:sp>
@@ -9730,6 +10645,7 @@
           <a:lstStyle/>
           <a:p>
             <a:pPr algn="ctr"/>
+            <a:endParaRPr/>
           </a:p>
         </p:txBody>
       </p:sp>
@@ -9822,7 +10738,7 @@
 </file>
 
 <file path=ppt/slides/slide3.xml><?xml version="1.0" encoding="utf-8"?>
-<p:sld xmlns:a="http://schemas.openxmlformats.org/drawingml/2006/main" xmlns:p="http://schemas.openxmlformats.org/presentationml/2006/main" xmlns:r="http://schemas.openxmlformats.org/officeDocument/2006/relationships">
+<p:sld xmlns:a="http://schemas.openxmlformats.org/drawingml/2006/main" xmlns:r="http://schemas.openxmlformats.org/officeDocument/2006/relationships" xmlns:p="http://schemas.openxmlformats.org/presentationml/2006/main">
   <p:cSld>
     <p:bg>
       <p:bgPr>
@@ -9838,7 +10754,14 @@
         <p:cNvGrpSpPr/>
         <p:nvPr/>
       </p:nvGrpSpPr>
-      <p:grpSpPr/>
+      <p:grpSpPr>
+        <a:xfrm>
+          <a:off x="0" y="0"/>
+          <a:ext cx="0" cy="0"/>
+          <a:chOff x="0" y="0"/>
+          <a:chExt cx="0" cy="0"/>
+        </a:xfrm>
+      </p:grpSpPr>
       <p:sp>
         <p:nvSpPr>
           <p:cNvPr id="2" name="TextBox 1"/>
@@ -9951,6 +10874,7 @@
           <a:lstStyle/>
           <a:p>
             <a:pPr algn="ctr"/>
+            <a:endParaRPr/>
           </a:p>
         </p:txBody>
       </p:sp>
@@ -10046,6 +10970,7 @@
           <a:lstStyle/>
           <a:p>
             <a:pPr algn="ctr"/>
+            <a:endParaRPr/>
           </a:p>
         </p:txBody>
       </p:sp>
@@ -10141,6 +11066,7 @@
           <a:lstStyle/>
           <a:p>
             <a:pPr algn="ctr"/>
+            <a:endParaRPr/>
           </a:p>
         </p:txBody>
       </p:sp>
@@ -10236,6 +11162,7 @@
           <a:lstStyle/>
           <a:p>
             <a:pPr algn="ctr"/>
+            <a:endParaRPr/>
           </a:p>
         </p:txBody>
       </p:sp>
@@ -10331,6 +11258,7 @@
           <a:lstStyle/>
           <a:p>
             <a:pPr algn="ctr"/>
+            <a:endParaRPr/>
           </a:p>
         </p:txBody>
       </p:sp>
@@ -10393,7 +11321,7 @@
 </file>
 
 <file path=ppt/slides/slide4.xml><?xml version="1.0" encoding="utf-8"?>
-<p:sld xmlns:a="http://schemas.openxmlformats.org/drawingml/2006/main" xmlns:p="http://schemas.openxmlformats.org/presentationml/2006/main" xmlns:r="http://schemas.openxmlformats.org/officeDocument/2006/relationships">
+<p:sld xmlns:a="http://schemas.openxmlformats.org/drawingml/2006/main" xmlns:r="http://schemas.openxmlformats.org/officeDocument/2006/relationships" xmlns:p="http://schemas.openxmlformats.org/presentationml/2006/main">
   <p:cSld>
     <p:bg>
       <p:bgPr>
@@ -10409,7 +11337,14 @@
         <p:cNvGrpSpPr/>
         <p:nvPr/>
       </p:nvGrpSpPr>
-      <p:grpSpPr/>
+      <p:grpSpPr>
+        <a:xfrm>
+          <a:off x="0" y="0"/>
+          <a:ext cx="0" cy="0"/>
+          <a:chOff x="0" y="0"/>
+          <a:chExt cx="0" cy="0"/>
+        </a:xfrm>
+      </p:grpSpPr>
       <p:sp>
         <p:nvSpPr>
           <p:cNvPr id="2" name="TextBox 1"/>
@@ -10522,6 +11457,7 @@
           <a:lstStyle/>
           <a:p>
             <a:pPr algn="ctr"/>
+            <a:endParaRPr/>
           </a:p>
         </p:txBody>
       </p:sp>
@@ -10692,6 +11628,7 @@
           <a:lstStyle/>
           <a:p>
             <a:pPr algn="ctr"/>
+            <a:endParaRPr/>
           </a:p>
         </p:txBody>
       </p:sp>
@@ -10862,6 +11799,7 @@
           <a:lstStyle/>
           <a:p>
             <a:pPr algn="ctr"/>
+            <a:endParaRPr/>
           </a:p>
         </p:txBody>
       </p:sp>
@@ -11032,6 +11970,7 @@
           <a:lstStyle/>
           <a:p>
             <a:pPr algn="ctr"/>
+            <a:endParaRPr/>
           </a:p>
         </p:txBody>
       </p:sp>
@@ -11169,7 +12108,7 @@
 </file>
 
 <file path=ppt/slides/slide5.xml><?xml version="1.0" encoding="utf-8"?>
-<p:sld xmlns:a="http://schemas.openxmlformats.org/drawingml/2006/main" xmlns:p="http://schemas.openxmlformats.org/presentationml/2006/main" xmlns:r="http://schemas.openxmlformats.org/officeDocument/2006/relationships">
+<p:sld xmlns:a="http://schemas.openxmlformats.org/drawingml/2006/main" xmlns:r="http://schemas.openxmlformats.org/officeDocument/2006/relationships" xmlns:p="http://schemas.openxmlformats.org/presentationml/2006/main">
   <p:cSld>
     <p:bg>
       <p:bgPr>
@@ -11185,7 +12124,14 @@
         <p:cNvGrpSpPr/>
         <p:nvPr/>
       </p:nvGrpSpPr>
-      <p:grpSpPr/>
+      <p:grpSpPr>
+        <a:xfrm>
+          <a:off x="0" y="0"/>
+          <a:ext cx="0" cy="0"/>
+          <a:chOff x="0" y="0"/>
+          <a:chExt cx="0" cy="0"/>
+        </a:xfrm>
+      </p:grpSpPr>
       <p:sp>
         <p:nvSpPr>
           <p:cNvPr id="2" name="TextBox 1"/>
@@ -11298,6 +12244,7 @@
           <a:lstStyle/>
           <a:p>
             <a:pPr algn="ctr"/>
+            <a:endParaRPr/>
           </a:p>
         </p:txBody>
       </p:sp>
@@ -11408,6 +12355,7 @@
           <a:lstStyle/>
           <a:p>
             <a:pPr algn="ctr"/>
+            <a:endParaRPr/>
           </a:p>
         </p:txBody>
       </p:sp>
@@ -11518,6 +12466,7 @@
           <a:lstStyle/>
           <a:p>
             <a:pPr algn="ctr"/>
+            <a:endParaRPr/>
           </a:p>
         </p:txBody>
       </p:sp>
@@ -11628,6 +12577,7 @@
           <a:lstStyle/>
           <a:p>
             <a:pPr algn="ctr"/>
+            <a:endParaRPr/>
           </a:p>
         </p:txBody>
       </p:sp>
@@ -11738,6 +12688,7 @@
           <a:lstStyle/>
           <a:p>
             <a:pPr algn="ctr"/>
+            <a:endParaRPr/>
           </a:p>
         </p:txBody>
       </p:sp>
@@ -11848,6 +12799,7 @@
           <a:lstStyle/>
           <a:p>
             <a:pPr algn="ctr"/>
+            <a:endParaRPr/>
           </a:p>
         </p:txBody>
       </p:sp>
@@ -11958,6 +12910,7 @@
           <a:lstStyle/>
           <a:p>
             <a:pPr algn="ctr"/>
+            <a:endParaRPr/>
           </a:p>
         </p:txBody>
       </p:sp>
@@ -12068,6 +13021,7 @@
           <a:lstStyle/>
           <a:p>
             <a:pPr algn="ctr"/>
+            <a:endParaRPr/>
           </a:p>
         </p:txBody>
       </p:sp>
@@ -12145,7 +13099,7 @@
 </file>
 
 <file path=ppt/slides/slide6.xml><?xml version="1.0" encoding="utf-8"?>
-<p:sld xmlns:a="http://schemas.openxmlformats.org/drawingml/2006/main" xmlns:p="http://schemas.openxmlformats.org/presentationml/2006/main" xmlns:r="http://schemas.openxmlformats.org/officeDocument/2006/relationships">
+<p:sld xmlns:a="http://schemas.openxmlformats.org/drawingml/2006/main" xmlns:r="http://schemas.openxmlformats.org/officeDocument/2006/relationships" xmlns:p="http://schemas.openxmlformats.org/presentationml/2006/main">
   <p:cSld>
     <p:bg>
       <p:bgPr>
@@ -12161,7 +13115,14 @@
         <p:cNvGrpSpPr/>
         <p:nvPr/>
       </p:nvGrpSpPr>
-      <p:grpSpPr/>
+      <p:grpSpPr>
+        <a:xfrm>
+          <a:off x="0" y="0"/>
+          <a:ext cx="0" cy="0"/>
+          <a:chOff x="0" y="0"/>
+          <a:chExt cx="0" cy="0"/>
+        </a:xfrm>
+      </p:grpSpPr>
       <p:sp>
         <p:nvSpPr>
           <p:cNvPr id="2" name="TextBox 1"/>
@@ -12274,6 +13235,7 @@
           <a:lstStyle/>
           <a:p>
             <a:pPr algn="ctr"/>
+            <a:endParaRPr/>
           </a:p>
         </p:txBody>
       </p:sp>
@@ -12444,6 +13406,7 @@
           <a:lstStyle/>
           <a:p>
             <a:pPr algn="ctr"/>
+            <a:endParaRPr/>
           </a:p>
         </p:txBody>
       </p:sp>
@@ -12457,14 +13420,15 @@
         </p:nvPicPr>
         <p:blipFill>
           <a:blip r:embed="rId2"/>
+          <a:srcRect/>
           <a:stretch>
             <a:fillRect/>
           </a:stretch>
         </p:blipFill>
         <p:spPr>
           <a:xfrm>
-            <a:off x="5696712" y="1444752"/>
-            <a:ext cx="5705856" cy="4425696"/>
+            <a:off x="5696712" y="1874520"/>
+            <a:ext cx="5705856" cy="3566160"/>
           </a:xfrm>
           <a:prstGeom prst="rect">
             <a:avLst/>
@@ -12515,7 +13479,7 @@
 </file>
 
 <file path=ppt/slides/slide7.xml><?xml version="1.0" encoding="utf-8"?>
-<p:sld xmlns:a="http://schemas.openxmlformats.org/drawingml/2006/main" xmlns:p="http://schemas.openxmlformats.org/presentationml/2006/main" xmlns:r="http://schemas.openxmlformats.org/officeDocument/2006/relationships">
+<p:sld xmlns:a="http://schemas.openxmlformats.org/drawingml/2006/main" xmlns:r="http://schemas.openxmlformats.org/officeDocument/2006/relationships" xmlns:p="http://schemas.openxmlformats.org/presentationml/2006/main">
   <p:cSld>
     <p:bg>
       <p:bgPr>
@@ -12531,7 +13495,14 @@
         <p:cNvGrpSpPr/>
         <p:nvPr/>
       </p:nvGrpSpPr>
-      <p:grpSpPr/>
+      <p:grpSpPr>
+        <a:xfrm>
+          <a:off x="0" y="0"/>
+          <a:ext cx="0" cy="0"/>
+          <a:chOff x="0" y="0"/>
+          <a:chExt cx="0" cy="0"/>
+        </a:xfrm>
+      </p:grpSpPr>
       <p:sp>
         <p:nvSpPr>
           <p:cNvPr id="2" name="TextBox 1"/>
@@ -12644,6 +13615,7 @@
           <a:lstStyle/>
           <a:p>
             <a:pPr algn="ctr"/>
+            <a:endParaRPr/>
           </a:p>
         </p:txBody>
       </p:sp>
@@ -12814,6 +13786,7 @@
           <a:lstStyle/>
           <a:p>
             <a:pPr algn="ctr"/>
+            <a:endParaRPr/>
           </a:p>
         </p:txBody>
       </p:sp>
@@ -12827,14 +13800,15 @@
         </p:nvPicPr>
         <p:blipFill>
           <a:blip r:embed="rId2"/>
+          <a:srcRect/>
           <a:stretch>
             <a:fillRect/>
           </a:stretch>
         </p:blipFill>
         <p:spPr>
           <a:xfrm>
-            <a:off x="5696712" y="1444752"/>
-            <a:ext cx="5705856" cy="4425696"/>
+            <a:off x="5696712" y="1874520"/>
+            <a:ext cx="5705856" cy="3566160"/>
           </a:xfrm>
           <a:prstGeom prst="rect">
             <a:avLst/>
@@ -12885,7 +13859,7 @@
 </file>
 
 <file path=ppt/slides/slide8.xml><?xml version="1.0" encoding="utf-8"?>
-<p:sld xmlns:a="http://schemas.openxmlformats.org/drawingml/2006/main" xmlns:p="http://schemas.openxmlformats.org/presentationml/2006/main" xmlns:r="http://schemas.openxmlformats.org/officeDocument/2006/relationships">
+<p:sld xmlns:a="http://schemas.openxmlformats.org/drawingml/2006/main" xmlns:r="http://schemas.openxmlformats.org/officeDocument/2006/relationships" xmlns:p="http://schemas.openxmlformats.org/presentationml/2006/main">
   <p:cSld>
     <p:bg>
       <p:bgPr>
@@ -12901,7 +13875,14 @@
         <p:cNvGrpSpPr/>
         <p:nvPr/>
       </p:nvGrpSpPr>
-      <p:grpSpPr/>
+      <p:grpSpPr>
+        <a:xfrm>
+          <a:off x="0" y="0"/>
+          <a:ext cx="0" cy="0"/>
+          <a:chOff x="0" y="0"/>
+          <a:chExt cx="0" cy="0"/>
+        </a:xfrm>
+      </p:grpSpPr>
       <p:sp>
         <p:nvSpPr>
           <p:cNvPr id="2" name="TextBox 1"/>
@@ -13014,6 +13995,7 @@
           <a:lstStyle/>
           <a:p>
             <a:pPr algn="ctr"/>
+            <a:endParaRPr/>
           </a:p>
         </p:txBody>
       </p:sp>
@@ -13184,6 +14166,7 @@
           <a:lstStyle/>
           <a:p>
             <a:pPr algn="ctr"/>
+            <a:endParaRPr/>
           </a:p>
         </p:txBody>
       </p:sp>
@@ -13197,14 +14180,15 @@
         </p:nvPicPr>
         <p:blipFill>
           <a:blip r:embed="rId2"/>
+          <a:srcRect/>
           <a:stretch>
             <a:fillRect/>
           </a:stretch>
         </p:blipFill>
         <p:spPr>
           <a:xfrm>
-            <a:off x="5696712" y="1444752"/>
-            <a:ext cx="5705856" cy="4425696"/>
+            <a:off x="5696712" y="1874520"/>
+            <a:ext cx="5705856" cy="3566160"/>
           </a:xfrm>
           <a:prstGeom prst="rect">
             <a:avLst/>
@@ -13255,7 +14239,7 @@
 </file>
 
 <file path=ppt/slides/slide9.xml><?xml version="1.0" encoding="utf-8"?>
-<p:sld xmlns:a="http://schemas.openxmlformats.org/drawingml/2006/main" xmlns:p="http://schemas.openxmlformats.org/presentationml/2006/main" xmlns:r="http://schemas.openxmlformats.org/officeDocument/2006/relationships">
+<p:sld xmlns:a="http://schemas.openxmlformats.org/drawingml/2006/main" xmlns:r="http://schemas.openxmlformats.org/officeDocument/2006/relationships" xmlns:p="http://schemas.openxmlformats.org/presentationml/2006/main">
   <p:cSld>
     <p:bg>
       <p:bgPr>
@@ -13271,7 +14255,14 @@
         <p:cNvGrpSpPr/>
         <p:nvPr/>
       </p:nvGrpSpPr>
-      <p:grpSpPr/>
+      <p:grpSpPr>
+        <a:xfrm>
+          <a:off x="0" y="0"/>
+          <a:ext cx="0" cy="0"/>
+          <a:chOff x="0" y="0"/>
+          <a:chExt cx="0" cy="0"/>
+        </a:xfrm>
+      </p:grpSpPr>
       <p:sp>
         <p:nvSpPr>
           <p:cNvPr id="2" name="TextBox 1"/>
@@ -13384,6 +14375,7 @@
           <a:lstStyle/>
           <a:p>
             <a:pPr algn="ctr"/>
+            <a:endParaRPr/>
           </a:p>
         </p:txBody>
       </p:sp>
@@ -13554,6 +14546,7 @@
           <a:lstStyle/>
           <a:p>
             <a:pPr algn="ctr"/>
+            <a:endParaRPr/>
           </a:p>
         </p:txBody>
       </p:sp>
@@ -13567,14 +14560,15 @@
         </p:nvPicPr>
         <p:blipFill>
           <a:blip r:embed="rId2"/>
+          <a:srcRect/>
           <a:stretch>
             <a:fillRect/>
           </a:stretch>
         </p:blipFill>
         <p:spPr>
           <a:xfrm>
-            <a:off x="5696712" y="1444752"/>
-            <a:ext cx="5705856" cy="4425696"/>
+            <a:off x="5696712" y="1874520"/>
+            <a:ext cx="5705856" cy="3566160"/>
           </a:xfrm>
           <a:prstGeom prst="rect">
             <a:avLst/>
@@ -13942,4 +14936,319 @@
   </a:objectDefaults>
   <a:extraClrSchemeLst/>
 </a:theme>
+</file>
+
+<file path=ppt/theme/theme2.xml><?xml version="1.0" encoding="utf-8"?>
+<a:theme xmlns:a="http://schemas.openxmlformats.org/drawingml/2006/main" name="Office Theme">
+  <a:themeElements>
+    <a:clrScheme name="Office">
+      <a:dk1>
+        <a:sysClr val="windowText" lastClr="000000"/>
+      </a:dk1>
+      <a:lt1>
+        <a:sysClr val="window" lastClr="FFFFFF"/>
+      </a:lt1>
+      <a:dk2>
+        <a:srgbClr val="0E2841"/>
+      </a:dk2>
+      <a:lt2>
+        <a:srgbClr val="E8E8E8"/>
+      </a:lt2>
+      <a:accent1>
+        <a:srgbClr val="156082"/>
+      </a:accent1>
+      <a:accent2>
+        <a:srgbClr val="E97132"/>
+      </a:accent2>
+      <a:accent3>
+        <a:srgbClr val="196B24"/>
+      </a:accent3>
+      <a:accent4>
+        <a:srgbClr val="0F9ED5"/>
+      </a:accent4>
+      <a:accent5>
+        <a:srgbClr val="A02B93"/>
+      </a:accent5>
+      <a:accent6>
+        <a:srgbClr val="4EA72E"/>
+      </a:accent6>
+      <a:hlink>
+        <a:srgbClr val="467886"/>
+      </a:hlink>
+      <a:folHlink>
+        <a:srgbClr val="96607D"/>
+      </a:folHlink>
+    </a:clrScheme>
+    <a:fontScheme name="Office">
+      <a:majorFont>
+        <a:latin typeface="Aptos Display" panose="02110004020202020204"/>
+        <a:ea typeface=""/>
+        <a:cs typeface=""/>
+        <a:font script="Jpan" typeface="游ゴシック Light"/>
+        <a:font script="Hang" typeface="맑은 고딕"/>
+        <a:font script="Hans" typeface="等线 Light"/>
+        <a:font script="Hant" typeface="新細明體"/>
+        <a:font script="Arab" typeface="Times New Roman"/>
+        <a:font script="Hebr" typeface="Times New Roman"/>
+        <a:font script="Thai" typeface="Angsana New"/>
+        <a:font script="Ethi" typeface="Nyala"/>
+        <a:font script="Beng" typeface="Vrinda"/>
+        <a:font script="Gujr" typeface="Shruti"/>
+        <a:font script="Khmr" typeface="MoolBoran"/>
+        <a:font script="Knda" typeface="Tunga"/>
+        <a:font script="Guru" typeface="Raavi"/>
+        <a:font script="Cans" typeface="Euphemia"/>
+        <a:font script="Cher" typeface="Plantagenet Cherokee"/>
+        <a:font script="Yiii" typeface="Microsoft Yi Baiti"/>
+        <a:font script="Tibt" typeface="Microsoft Himalaya"/>
+        <a:font script="Thaa" typeface="MV Boli"/>
+        <a:font script="Deva" typeface="Mangal"/>
+        <a:font script="Telu" typeface="Gautami"/>
+        <a:font script="Taml" typeface="Latha"/>
+        <a:font script="Syrc" typeface="Estrangelo Edessa"/>
+        <a:font script="Orya" typeface="Kalinga"/>
+        <a:font script="Mlym" typeface="Kartika"/>
+        <a:font script="Laoo" typeface="DokChampa"/>
+        <a:font script="Sinh" typeface="Iskoola Pota"/>
+        <a:font script="Mong" typeface="Mongolian Baiti"/>
+        <a:font script="Viet" typeface="Times New Roman"/>
+        <a:font script="Uigh" typeface="Microsoft Uighur"/>
+        <a:font script="Geor" typeface="Sylfaen"/>
+        <a:font script="Armn" typeface="Arial"/>
+        <a:font script="Bugi" typeface="Leelawadee UI"/>
+        <a:font script="Bopo" typeface="Microsoft JhengHei"/>
+        <a:font script="Java" typeface="Javanese Text"/>
+        <a:font script="Lisu" typeface="Segoe UI"/>
+        <a:font script="Mymr" typeface="Myanmar Text"/>
+        <a:font script="Nkoo" typeface="Ebrima"/>
+        <a:font script="Olck" typeface="Nirmala UI"/>
+        <a:font script="Osma" typeface="Ebrima"/>
+        <a:font script="Phag" typeface="Phagspa"/>
+        <a:font script="Syrn" typeface="Estrangelo Edessa"/>
+        <a:font script="Syrj" typeface="Estrangelo Edessa"/>
+        <a:font script="Syre" typeface="Estrangelo Edessa"/>
+        <a:font script="Sora" typeface="Nirmala UI"/>
+        <a:font script="Tale" typeface="Microsoft Tai Le"/>
+        <a:font script="Talu" typeface="Microsoft New Tai Lue"/>
+        <a:font script="Tfng" typeface="Ebrima"/>
+      </a:majorFont>
+      <a:minorFont>
+        <a:latin typeface="Aptos" panose="02110004020202020204"/>
+        <a:ea typeface=""/>
+        <a:cs typeface=""/>
+        <a:font script="Jpan" typeface="游ゴシック"/>
+        <a:font script="Hang" typeface="맑은 고딕"/>
+        <a:font script="Hans" typeface="等线"/>
+        <a:font script="Hant" typeface="新細明體"/>
+        <a:font script="Arab" typeface="Arial"/>
+        <a:font script="Hebr" typeface="Arial"/>
+        <a:font script="Thai" typeface="Cordia New"/>
+        <a:font script="Ethi" typeface="Nyala"/>
+        <a:font script="Beng" typeface="Vrinda"/>
+        <a:font script="Gujr" typeface="Shruti"/>
+        <a:font script="Khmr" typeface="DaunPenh"/>
+        <a:font script="Knda" typeface="Tunga"/>
+        <a:font script="Guru" typeface="Raavi"/>
+        <a:font script="Cans" typeface="Euphemia"/>
+        <a:font script="Cher" typeface="Plantagenet Cherokee"/>
+        <a:font script="Yiii" typeface="Microsoft Yi Baiti"/>
+        <a:font script="Tibt" typeface="Microsoft Himalaya"/>
+        <a:font script="Thaa" typeface="MV Boli"/>
+        <a:font script="Deva" typeface="Mangal"/>
+        <a:font script="Telu" typeface="Gautami"/>
+        <a:font script="Taml" typeface="Latha"/>
+        <a:font script="Syrc" typeface="Estrangelo Edessa"/>
+        <a:font script="Orya" typeface="Kalinga"/>
+        <a:font script="Mlym" typeface="Kartika"/>
+        <a:font script="Laoo" typeface="DokChampa"/>
+        <a:font script="Sinh" typeface="Iskoola Pota"/>
+        <a:font script="Mong" typeface="Mongolian Baiti"/>
+        <a:font script="Viet" typeface="Arial"/>
+        <a:font script="Uigh" typeface="Microsoft Uighur"/>
+        <a:font script="Geor" typeface="Sylfaen"/>
+        <a:font script="Armn" typeface="Arial"/>
+        <a:font script="Bugi" typeface="Leelawadee UI"/>
+        <a:font script="Bopo" typeface="Microsoft JhengHei"/>
+        <a:font script="Java" typeface="Javanese Text"/>
+        <a:font script="Lisu" typeface="Segoe UI"/>
+        <a:font script="Mymr" typeface="Myanmar Text"/>
+        <a:font script="Nkoo" typeface="Ebrima"/>
+        <a:font script="Olck" typeface="Nirmala UI"/>
+        <a:font script="Osma" typeface="Ebrima"/>
+        <a:font script="Phag" typeface="Phagspa"/>
+        <a:font script="Syrn" typeface="Estrangelo Edessa"/>
+        <a:font script="Syrj" typeface="Estrangelo Edessa"/>
+        <a:font script="Syre" typeface="Estrangelo Edessa"/>
+        <a:font script="Sora" typeface="Nirmala UI"/>
+        <a:font script="Tale" typeface="Microsoft Tai Le"/>
+        <a:font script="Talu" typeface="Microsoft New Tai Lue"/>
+        <a:font script="Tfng" typeface="Ebrima"/>
+      </a:minorFont>
+    </a:fontScheme>
+    <a:fmtScheme name="Office">
+      <a:fillStyleLst>
+        <a:solidFill>
+          <a:schemeClr val="phClr"/>
+        </a:solidFill>
+        <a:gradFill rotWithShape="1">
+          <a:gsLst>
+            <a:gs pos="0">
+              <a:schemeClr val="phClr">
+                <a:lumMod val="110000"/>
+                <a:satMod val="105000"/>
+                <a:tint val="67000"/>
+              </a:schemeClr>
+            </a:gs>
+            <a:gs pos="50000">
+              <a:schemeClr val="phClr">
+                <a:lumMod val="105000"/>
+                <a:satMod val="103000"/>
+                <a:tint val="73000"/>
+              </a:schemeClr>
+            </a:gs>
+            <a:gs pos="100000">
+              <a:schemeClr val="phClr">
+                <a:lumMod val="105000"/>
+                <a:satMod val="109000"/>
+                <a:tint val="81000"/>
+              </a:schemeClr>
+            </a:gs>
+          </a:gsLst>
+          <a:lin ang="5400000" scaled="0"/>
+        </a:gradFill>
+        <a:gradFill rotWithShape="1">
+          <a:gsLst>
+            <a:gs pos="0">
+              <a:schemeClr val="phClr">
+                <a:satMod val="103000"/>
+                <a:lumMod val="102000"/>
+                <a:tint val="94000"/>
+              </a:schemeClr>
+            </a:gs>
+            <a:gs pos="50000">
+              <a:schemeClr val="phClr">
+                <a:satMod val="110000"/>
+                <a:lumMod val="100000"/>
+                <a:shade val="100000"/>
+              </a:schemeClr>
+            </a:gs>
+            <a:gs pos="100000">
+              <a:schemeClr val="phClr">
+                <a:lumMod val="99000"/>
+                <a:satMod val="120000"/>
+                <a:shade val="78000"/>
+              </a:schemeClr>
+            </a:gs>
+          </a:gsLst>
+          <a:lin ang="5400000" scaled="0"/>
+        </a:gradFill>
+      </a:fillStyleLst>
+      <a:lnStyleLst>
+        <a:ln w="12700" cap="flat" cmpd="sng" algn="ctr">
+          <a:solidFill>
+            <a:schemeClr val="phClr"/>
+          </a:solidFill>
+          <a:prstDash val="solid"/>
+          <a:miter lim="800000"/>
+        </a:ln>
+        <a:ln w="19050" cap="flat" cmpd="sng" algn="ctr">
+          <a:solidFill>
+            <a:schemeClr val="phClr"/>
+          </a:solidFill>
+          <a:prstDash val="solid"/>
+          <a:miter lim="800000"/>
+        </a:ln>
+        <a:ln w="25400" cap="flat" cmpd="sng" algn="ctr">
+          <a:solidFill>
+            <a:schemeClr val="phClr"/>
+          </a:solidFill>
+          <a:prstDash val="solid"/>
+          <a:miter lim="800000"/>
+        </a:ln>
+      </a:lnStyleLst>
+      <a:effectStyleLst>
+        <a:effectStyle>
+          <a:effectLst/>
+        </a:effectStyle>
+        <a:effectStyle>
+          <a:effectLst/>
+        </a:effectStyle>
+        <a:effectStyle>
+          <a:effectLst>
+            <a:outerShdw blurRad="57150" dist="19050" dir="5400000" algn="ctr" rotWithShape="0">
+              <a:srgbClr val="000000">
+                <a:alpha val="63000"/>
+              </a:srgbClr>
+            </a:outerShdw>
+          </a:effectLst>
+        </a:effectStyle>
+      </a:effectStyleLst>
+      <a:bgFillStyleLst>
+        <a:solidFill>
+          <a:schemeClr val="phClr"/>
+        </a:solidFill>
+        <a:solidFill>
+          <a:schemeClr val="phClr">
+            <a:tint val="95000"/>
+            <a:satMod val="170000"/>
+          </a:schemeClr>
+        </a:solidFill>
+        <a:gradFill rotWithShape="1">
+          <a:gsLst>
+            <a:gs pos="0">
+              <a:schemeClr val="phClr">
+                <a:tint val="93000"/>
+                <a:satMod val="150000"/>
+                <a:shade val="98000"/>
+                <a:lumMod val="102000"/>
+              </a:schemeClr>
+            </a:gs>
+            <a:gs pos="50000">
+              <a:schemeClr val="phClr">
+                <a:tint val="98000"/>
+                <a:satMod val="130000"/>
+                <a:shade val="90000"/>
+                <a:lumMod val="103000"/>
+              </a:schemeClr>
+            </a:gs>
+            <a:gs pos="100000">
+              <a:schemeClr val="phClr">
+                <a:shade val="63000"/>
+                <a:satMod val="120000"/>
+              </a:schemeClr>
+            </a:gs>
+          </a:gsLst>
+          <a:lin ang="5400000" scaled="0"/>
+        </a:gradFill>
+      </a:bgFillStyleLst>
+    </a:fmtScheme>
+  </a:themeElements>
+  <a:objectDefaults>
+    <a:lnDef>
+      <a:spPr/>
+      <a:bodyPr/>
+      <a:lstStyle/>
+      <a:style>
+        <a:lnRef idx="2">
+          <a:schemeClr val="accent1"/>
+        </a:lnRef>
+        <a:fillRef idx="0">
+          <a:schemeClr val="accent1"/>
+        </a:fillRef>
+        <a:effectRef idx="1">
+          <a:schemeClr val="accent1"/>
+        </a:effectRef>
+        <a:fontRef idx="minor">
+          <a:schemeClr val="tx1"/>
+        </a:fontRef>
+      </a:style>
+    </a:lnDef>
+  </a:objectDefaults>
+  <a:extraClrSchemeLst/>
+  <a:extLst>
+    <a:ext uri="{05A4C25C-085E-4340-85A3-A5531E510DB2}">
+      <thm15:themeFamily xmlns:thm15="http://schemas.microsoft.com/office/thememl/2012/main" name="Office Theme" id="{2E142A2C-CD16-42D6-873A-C26D2A0506FA}" vid="{1BDDFF52-6CD6-40A5-AB3C-68EB2F1E4D0A}"/>
+    </a:ext>
+  </a:extLst>
+</a:theme>
 </file>
</xml_diff>